<commit_message>
Deck v2: enlarged ISN logo on cover, added all-in-one services panel, cinematic full-bleed redesign of slides 7/9/10/11/12 with dark gradient overlays
</commit_message>
<xml_diff>
--- a/public/presentations/ISN-Customs-Brokerage-Deck.pptx
+++ b/public/presentations/ISN-Customs-Brokerage-Deck.pptx
@@ -3189,7 +3189,7 @@
           </a:prstGeom>
           <a:solidFill>
             <a:srgbClr val="05070B">
-              <a:alpha val="55000"/>
+              <a:alpha val="57999"/>
             </a:srgbClr>
           </a:solidFill>
           <a:ln>
@@ -3236,7 +3236,7 @@
         <p:spPr>
           <a:xfrm>
             <a:off x="548640" y="502920"/>
-            <a:ext cx="1371600" cy="797300"/>
+            <a:ext cx="2377440" cy="1381986"/>
           </a:xfrm>
           <a:prstGeom prst="rect">
             <a:avLst/>
@@ -3245,7 +3245,324 @@
       </p:pic>
       <p:sp>
         <p:nvSpPr>
-          <p:cNvPr id="6" name="TextBox 5"/>
+          <p:cNvPr id="6" name="Rectangle 5"/>
+          <p:cNvSpPr/>
+          <p:nvPr/>
+        </p:nvSpPr>
+        <p:spPr>
+          <a:xfrm>
+            <a:off x="7498079" y="667512"/>
+            <a:ext cx="548640" cy="8000"/>
+          </a:xfrm>
+          <a:prstGeom prst="rect">
+            <a:avLst/>
+          </a:prstGeom>
+          <a:solidFill>
+            <a:srgbClr val="3AA0FF"/>
+          </a:solidFill>
+          <a:ln>
+            <a:noFill/>
+          </a:ln>
+          <a:effectLst/>
+        </p:spPr>
+        <p:style>
+          <a:lnRef idx="1">
+            <a:schemeClr val="accent1"/>
+          </a:lnRef>
+          <a:fillRef idx="3">
+            <a:schemeClr val="accent1"/>
+          </a:fillRef>
+          <a:effectRef idx="2">
+            <a:schemeClr val="accent1"/>
+          </a:effectRef>
+          <a:fontRef idx="minor">
+            <a:schemeClr val="lt1"/>
+          </a:fontRef>
+        </p:style>
+        <p:txBody>
+          <a:bodyPr rtlCol="0" anchor="ctr"/>
+          <a:lstStyle/>
+          <a:p>
+            <a:pPr algn="ctr"/>
+          </a:p>
+        </p:txBody>
+      </p:sp>
+      <p:sp>
+        <p:nvSpPr>
+          <p:cNvPr id="7" name="TextBox 6"/>
+          <p:cNvSpPr txBox="1"/>
+          <p:nvPr/>
+        </p:nvSpPr>
+        <p:spPr>
+          <a:xfrm>
+            <a:off x="7498079" y="868680"/>
+            <a:ext cx="4160520" cy="292608"/>
+          </a:xfrm>
+          <a:prstGeom prst="rect">
+            <a:avLst/>
+          </a:prstGeom>
+          <a:noFill/>
+        </p:spPr>
+        <p:txBody>
+          <a:bodyPr wrap="square" lIns="0" rIns="0" tIns="0" bIns="0" anchor="t">
+            <a:spAutoFit/>
+          </a:bodyPr>
+          <a:lstStyle/>
+          <a:p>
+            <a:pPr algn="l">
+              <a:lnSpc>
+                <a:spcPct val="115000"/>
+              </a:lnSpc>
+            </a:pPr>
+            <a:r>
+              <a:rPr sz="950" b="1" spc="300">
+                <a:solidFill>
+                  <a:srgbClr val="3AA0FF"/>
+                </a:solidFill>
+                <a:latin typeface="Helvetica Neue"/>
+              </a:rPr>
+              <a:t>FULL-SERVICE GLOBAL LOGISTICS PROVIDER</a:t>
+            </a:r>
+          </a:p>
+        </p:txBody>
+      </p:sp>
+      <p:sp>
+        <p:nvSpPr>
+          <p:cNvPr id="8" name="TextBox 7"/>
+          <p:cNvSpPr txBox="1"/>
+          <p:nvPr/>
+        </p:nvSpPr>
+        <p:spPr>
+          <a:xfrm>
+            <a:off x="7498079" y="1371600"/>
+            <a:ext cx="4160520" cy="292608"/>
+          </a:xfrm>
+          <a:prstGeom prst="rect">
+            <a:avLst/>
+          </a:prstGeom>
+          <a:noFill/>
+        </p:spPr>
+        <p:txBody>
+          <a:bodyPr wrap="square" lIns="0" rIns="0" tIns="0" bIns="0" anchor="t">
+            <a:spAutoFit/>
+          </a:bodyPr>
+          <a:lstStyle/>
+          <a:p>
+            <a:pPr algn="l">
+              <a:lnSpc>
+                <a:spcPct val="100000"/>
+              </a:lnSpc>
+            </a:pPr>
+            <a:r>
+              <a:rPr sz="1250" b="0" spc="-10">
+                <a:solidFill>
+                  <a:srgbClr val="FFFFFF"/>
+                </a:solidFill>
+                <a:latin typeface="Helvetica Neue"/>
+              </a:rPr>
+              <a:t>Customs Brokerage</a:t>
+            </a:r>
+          </a:p>
+        </p:txBody>
+      </p:sp>
+      <p:sp>
+        <p:nvSpPr>
+          <p:cNvPr id="9" name="TextBox 8"/>
+          <p:cNvSpPr txBox="1"/>
+          <p:nvPr/>
+        </p:nvSpPr>
+        <p:spPr>
+          <a:xfrm>
+            <a:off x="7498079" y="1700784"/>
+            <a:ext cx="4160520" cy="292608"/>
+          </a:xfrm>
+          <a:prstGeom prst="rect">
+            <a:avLst/>
+          </a:prstGeom>
+          <a:noFill/>
+        </p:spPr>
+        <p:txBody>
+          <a:bodyPr wrap="square" lIns="0" rIns="0" tIns="0" bIns="0" anchor="t">
+            <a:spAutoFit/>
+          </a:bodyPr>
+          <a:lstStyle/>
+          <a:p>
+            <a:pPr algn="l">
+              <a:lnSpc>
+                <a:spcPct val="100000"/>
+              </a:lnSpc>
+            </a:pPr>
+            <a:r>
+              <a:rPr sz="1250" b="0" spc="-10">
+                <a:solidFill>
+                  <a:srgbClr val="FFFFFF"/>
+                </a:solidFill>
+                <a:latin typeface="Helvetica Neue"/>
+              </a:rPr>
+              <a:t>Freight Forwarding</a:t>
+            </a:r>
+          </a:p>
+        </p:txBody>
+      </p:sp>
+      <p:sp>
+        <p:nvSpPr>
+          <p:cNvPr id="10" name="TextBox 9"/>
+          <p:cNvSpPr txBox="1"/>
+          <p:nvPr/>
+        </p:nvSpPr>
+        <p:spPr>
+          <a:xfrm>
+            <a:off x="7498079" y="2029968"/>
+            <a:ext cx="4160520" cy="292608"/>
+          </a:xfrm>
+          <a:prstGeom prst="rect">
+            <a:avLst/>
+          </a:prstGeom>
+          <a:noFill/>
+        </p:spPr>
+        <p:txBody>
+          <a:bodyPr wrap="square" lIns="0" rIns="0" tIns="0" bIns="0" anchor="t">
+            <a:spAutoFit/>
+          </a:bodyPr>
+          <a:lstStyle/>
+          <a:p>
+            <a:pPr algn="l">
+              <a:lnSpc>
+                <a:spcPct val="100000"/>
+              </a:lnSpc>
+            </a:pPr>
+            <a:r>
+              <a:rPr sz="1250" b="0" spc="-10">
+                <a:solidFill>
+                  <a:srgbClr val="FFFFFF"/>
+                </a:solidFill>
+                <a:latin typeface="Helvetica Neue"/>
+              </a:rPr>
+              <a:t>Ocean · Air · Ground</a:t>
+            </a:r>
+          </a:p>
+        </p:txBody>
+      </p:sp>
+      <p:sp>
+        <p:nvSpPr>
+          <p:cNvPr id="11" name="TextBox 10"/>
+          <p:cNvSpPr txBox="1"/>
+          <p:nvPr/>
+        </p:nvSpPr>
+        <p:spPr>
+          <a:xfrm>
+            <a:off x="7498079" y="2359152"/>
+            <a:ext cx="4160520" cy="292608"/>
+          </a:xfrm>
+          <a:prstGeom prst="rect">
+            <a:avLst/>
+          </a:prstGeom>
+          <a:noFill/>
+        </p:spPr>
+        <p:txBody>
+          <a:bodyPr wrap="square" lIns="0" rIns="0" tIns="0" bIns="0" anchor="t">
+            <a:spAutoFit/>
+          </a:bodyPr>
+          <a:lstStyle/>
+          <a:p>
+            <a:pPr algn="l">
+              <a:lnSpc>
+                <a:spcPct val="100000"/>
+              </a:lnSpc>
+            </a:pPr>
+            <a:r>
+              <a:rPr sz="1250" b="0" spc="-10">
+                <a:solidFill>
+                  <a:srgbClr val="FFFFFF"/>
+                </a:solidFill>
+                <a:latin typeface="Helvetica Neue"/>
+              </a:rPr>
+              <a:t>Bonded Yard &amp; Freight</a:t>
+            </a:r>
+          </a:p>
+        </p:txBody>
+      </p:sp>
+      <p:sp>
+        <p:nvSpPr>
+          <p:cNvPr id="12" name="TextBox 11"/>
+          <p:cNvSpPr txBox="1"/>
+          <p:nvPr/>
+        </p:nvSpPr>
+        <p:spPr>
+          <a:xfrm>
+            <a:off x="7498079" y="2688336"/>
+            <a:ext cx="4160520" cy="292608"/>
+          </a:xfrm>
+          <a:prstGeom prst="rect">
+            <a:avLst/>
+          </a:prstGeom>
+          <a:noFill/>
+        </p:spPr>
+        <p:txBody>
+          <a:bodyPr wrap="square" lIns="0" rIns="0" tIns="0" bIns="0" anchor="t">
+            <a:spAutoFit/>
+          </a:bodyPr>
+          <a:lstStyle/>
+          <a:p>
+            <a:pPr algn="l">
+              <a:lnSpc>
+                <a:spcPct val="100000"/>
+              </a:lnSpc>
+            </a:pPr>
+            <a:r>
+              <a:rPr sz="1250" b="0" spc="-10">
+                <a:solidFill>
+                  <a:srgbClr val="FFFFFF"/>
+                </a:solidFill>
+                <a:latin typeface="Helvetica Neue"/>
+              </a:rPr>
+              <a:t>Logistics Brokerage</a:t>
+            </a:r>
+          </a:p>
+        </p:txBody>
+      </p:sp>
+      <p:sp>
+        <p:nvSpPr>
+          <p:cNvPr id="13" name="TextBox 12"/>
+          <p:cNvSpPr txBox="1"/>
+          <p:nvPr/>
+        </p:nvSpPr>
+        <p:spPr>
+          <a:xfrm>
+            <a:off x="7498079" y="3017520"/>
+            <a:ext cx="4160520" cy="292608"/>
+          </a:xfrm>
+          <a:prstGeom prst="rect">
+            <a:avLst/>
+          </a:prstGeom>
+          <a:noFill/>
+        </p:spPr>
+        <p:txBody>
+          <a:bodyPr wrap="square" lIns="0" rIns="0" tIns="0" bIns="0" anchor="t">
+            <a:spAutoFit/>
+          </a:bodyPr>
+          <a:lstStyle/>
+          <a:p>
+            <a:pPr algn="l">
+              <a:lnSpc>
+                <a:spcPct val="100000"/>
+              </a:lnSpc>
+            </a:pPr>
+            <a:r>
+              <a:rPr sz="1250" b="0" spc="-10">
+                <a:solidFill>
+                  <a:srgbClr val="FFFFFF"/>
+                </a:solidFill>
+                <a:latin typeface="Helvetica Neue"/>
+              </a:rPr>
+              <a:t>Import &amp; Export Solutions</a:t>
+            </a:r>
+          </a:p>
+        </p:txBody>
+      </p:sp>
+      <p:sp>
+        <p:nvSpPr>
+          <p:cNvPr id="14" name="TextBox 13"/>
           <p:cNvSpPr txBox="1"/>
           <p:nvPr/>
         </p:nvSpPr>
@@ -3284,7 +3601,7 @@
       </p:sp>
       <p:sp>
         <p:nvSpPr>
-          <p:cNvPr id="7" name="TextBox 6"/>
+          <p:cNvPr id="15" name="TextBox 14"/>
           <p:cNvSpPr txBox="1"/>
           <p:nvPr/>
         </p:nvSpPr>
@@ -3323,7 +3640,7 @@
       </p:sp>
       <p:sp>
         <p:nvSpPr>
-          <p:cNvPr id="8" name="TextBox 7"/>
+          <p:cNvPr id="16" name="TextBox 15"/>
           <p:cNvSpPr txBox="1"/>
           <p:nvPr/>
         </p:nvSpPr>
@@ -3356,46 +3673,6 @@
                 <a:latin typeface="Helvetica Neue"/>
               </a:rPr>
               <a:t>of your border.</a:t>
-            </a:r>
-          </a:p>
-        </p:txBody>
-      </p:sp>
-      <p:sp>
-        <p:nvSpPr>
-          <p:cNvPr id="9" name="TextBox 8"/>
-          <p:cNvSpPr txBox="1"/>
-          <p:nvPr/>
-        </p:nvSpPr>
-        <p:spPr>
-          <a:xfrm>
-            <a:off x="6858000" y="548640"/>
-            <a:ext cx="4846320" cy="914400"/>
-          </a:xfrm>
-          <a:prstGeom prst="rect">
-            <a:avLst/>
-          </a:prstGeom>
-          <a:noFill/>
-        </p:spPr>
-        <p:txBody>
-          <a:bodyPr wrap="square" lIns="0" rIns="0" tIns="0" bIns="0" anchor="t">
-            <a:spAutoFit/>
-          </a:bodyPr>
-          <a:lstStyle/>
-          <a:p>
-            <a:pPr algn="r">
-              <a:lnSpc>
-                <a:spcPct val="140000"/>
-              </a:lnSpc>
-            </a:pPr>
-            <a:r>
-              <a:rPr sz="1200" b="0">
-                <a:solidFill>
-                  <a:srgbClr val="BCC3CF"/>
-                </a:solidFill>
-                <a:latin typeface="Helvetica Neue"/>
-              </a:rPr>
-              <a:t>Licensed U.S. customs brokerage,
-freight forwarding, and integrated logistics.</a:t>
             </a:r>
           </a:p>
         </p:txBody>
@@ -3478,8 +3755,8 @@
         </p:blipFill>
         <p:spPr>
           <a:xfrm>
-            <a:off x="5943600" y="0"/>
-            <a:ext cx="6245352" cy="6858000"/>
+            <a:off x="0" y="0"/>
+            <a:ext cx="12191695" cy="6858000"/>
           </a:xfrm>
           <a:prstGeom prst="rect">
             <a:avLst/>
@@ -3495,18 +3772,30 @@
         <p:spPr>
           <a:xfrm>
             <a:off x="0" y="0"/>
-            <a:ext cx="5943600" cy="6858000"/>
-          </a:xfrm>
-          <a:prstGeom prst="rect">
-            <a:avLst/>
-          </a:prstGeom>
-          <a:solidFill>
-            <a:srgbClr val="05070B"/>
-          </a:solidFill>
+            <a:ext cx="12191695" cy="6858000"/>
+          </a:xfrm>
+          <a:prstGeom prst="rect">
+            <a:avLst/>
+          </a:prstGeom>
           <a:ln>
             <a:noFill/>
           </a:ln>
           <a:effectLst/>
+          <a:gradFill flip="none" rotWithShape="1">
+            <a:gsLst>
+              <a:gs pos="0">
+                <a:srgbClr val="05070B">
+                  <a:alpha val="88000"/>
+                </a:srgbClr>
+              </a:gs>
+              <a:gs pos="100000">
+                <a:srgbClr val="05070B">
+                  <a:alpha val="10000"/>
+                </a:srgbClr>
+              </a:gs>
+            </a:gsLst>
+            <a:lin ang="0" scaled="0"/>
+          </a:gradFill>
         </p:spPr>
         <p:style>
           <a:lnRef idx="1">
@@ -3533,6 +3822,62 @@
       <p:sp>
         <p:nvSpPr>
           <p:cNvPr id="5" name="Rectangle 4"/>
+          <p:cNvSpPr/>
+          <p:nvPr/>
+        </p:nvSpPr>
+        <p:spPr>
+          <a:xfrm>
+            <a:off x="0" y="4114800"/>
+            <a:ext cx="12191695" cy="2743200"/>
+          </a:xfrm>
+          <a:prstGeom prst="rect">
+            <a:avLst/>
+          </a:prstGeom>
+          <a:ln>
+            <a:noFill/>
+          </a:ln>
+          <a:effectLst/>
+          <a:gradFill flip="none" rotWithShape="1">
+            <a:gsLst>
+              <a:gs pos="0">
+                <a:srgbClr val="05070B">
+                  <a:alpha val="0"/>
+                </a:srgbClr>
+              </a:gs>
+              <a:gs pos="100000">
+                <a:srgbClr val="05070B">
+                  <a:alpha val="72000"/>
+                </a:srgbClr>
+              </a:gs>
+            </a:gsLst>
+            <a:lin ang="5400000" scaled="0"/>
+          </a:gradFill>
+        </p:spPr>
+        <p:style>
+          <a:lnRef idx="1">
+            <a:schemeClr val="accent1"/>
+          </a:lnRef>
+          <a:fillRef idx="3">
+            <a:schemeClr val="accent1"/>
+          </a:fillRef>
+          <a:effectRef idx="2">
+            <a:schemeClr val="accent1"/>
+          </a:effectRef>
+          <a:fontRef idx="minor">
+            <a:schemeClr val="lt1"/>
+          </a:fontRef>
+        </p:style>
+        <p:txBody>
+          <a:bodyPr rtlCol="0" anchor="ctr"/>
+          <a:lstStyle/>
+          <a:p>
+            <a:pPr algn="ctr"/>
+          </a:p>
+        </p:txBody>
+      </p:sp>
+      <p:sp>
+        <p:nvSpPr>
+          <p:cNvPr id="6" name="Rectangle 5"/>
           <p:cNvSpPr/>
           <p:nvPr/>
         </p:nvSpPr>
@@ -3576,7 +3921,7 @@
       </p:sp>
       <p:sp>
         <p:nvSpPr>
-          <p:cNvPr id="6" name="TextBox 5"/>
+          <p:cNvPr id="7" name="TextBox 6"/>
           <p:cNvSpPr txBox="1"/>
           <p:nvPr/>
         </p:nvSpPr>
@@ -3615,14 +3960,14 @@
       </p:sp>
       <p:sp>
         <p:nvSpPr>
-          <p:cNvPr id="7" name="TextBox 6"/>
-          <p:cNvSpPr txBox="1"/>
-          <p:nvPr/>
-        </p:nvSpPr>
-        <p:spPr>
-          <a:xfrm>
-            <a:off x="548640" y="2011680"/>
-            <a:ext cx="5303520" cy="868680"/>
+          <p:cNvPr id="8" name="TextBox 7"/>
+          <p:cNvSpPr txBox="1"/>
+          <p:nvPr/>
+        </p:nvSpPr>
+        <p:spPr>
+          <a:xfrm>
+            <a:off x="548640" y="2377440"/>
+            <a:ext cx="7772400" cy="960120"/>
           </a:xfrm>
           <a:prstGeom prst="rect">
             <a:avLst/>
@@ -3641,7 +3986,7 @@
               </a:lnSpc>
             </a:pPr>
             <a:r>
-              <a:rPr sz="4600" b="1" spc="-150">
+              <a:rPr sz="5800" b="1" spc="-180">
                 <a:solidFill>
                   <a:srgbClr val="FFFFFF"/>
                 </a:solidFill>
@@ -3654,14 +3999,14 @@
       </p:sp>
       <p:sp>
         <p:nvSpPr>
-          <p:cNvPr id="8" name="TextBox 7"/>
-          <p:cNvSpPr txBox="1"/>
-          <p:nvPr/>
-        </p:nvSpPr>
-        <p:spPr>
-          <a:xfrm>
-            <a:off x="548640" y="2697480"/>
-            <a:ext cx="5303520" cy="868680"/>
+          <p:cNvPr id="9" name="TextBox 8"/>
+          <p:cNvSpPr txBox="1"/>
+          <p:nvPr/>
+        </p:nvSpPr>
+        <p:spPr>
+          <a:xfrm>
+            <a:off x="548640" y="3246120"/>
+            <a:ext cx="10058400" cy="960120"/>
           </a:xfrm>
           <a:prstGeom prst="rect">
             <a:avLst/>
@@ -3680,7 +4025,7 @@
               </a:lnSpc>
             </a:pPr>
             <a:r>
-              <a:rPr sz="4600" b="1" spc="-150">
+              <a:rPr sz="5800" b="1" spc="-180">
                 <a:solidFill>
                   <a:srgbClr val="3AA0FF"/>
                 </a:solidFill>
@@ -3693,13 +4038,13 @@
       </p:sp>
       <p:sp>
         <p:nvSpPr>
-          <p:cNvPr id="9" name="Rectangle 8"/>
+          <p:cNvPr id="10" name="Rectangle 9"/>
           <p:cNvSpPr/>
           <p:nvPr/>
         </p:nvSpPr>
         <p:spPr>
           <a:xfrm>
-            <a:off x="548640" y="4169664"/>
+            <a:off x="548640" y="4901184"/>
             <a:ext cx="228600" cy="8000"/>
           </a:xfrm>
           <a:prstGeom prst="rect">
@@ -3737,14 +4082,14 @@
       </p:sp>
       <p:sp>
         <p:nvSpPr>
-          <p:cNvPr id="10" name="TextBox 9"/>
-          <p:cNvSpPr txBox="1"/>
-          <p:nvPr/>
-        </p:nvSpPr>
-        <p:spPr>
-          <a:xfrm>
-            <a:off x="868680" y="4023360"/>
-            <a:ext cx="4846320" cy="411480"/>
+          <p:cNvPr id="11" name="TextBox 10"/>
+          <p:cNvSpPr txBox="1"/>
+          <p:nvPr/>
+        </p:nvSpPr>
+        <p:spPr>
+          <a:xfrm>
+            <a:off x="868680" y="4754880"/>
+            <a:ext cx="7772400" cy="365760"/>
           </a:xfrm>
           <a:prstGeom prst="rect">
             <a:avLst/>
@@ -3776,13 +4121,13 @@
       </p:sp>
       <p:sp>
         <p:nvSpPr>
-          <p:cNvPr id="11" name="Rectangle 10"/>
+          <p:cNvPr id="12" name="Rectangle 11"/>
           <p:cNvSpPr/>
           <p:nvPr/>
         </p:nvSpPr>
         <p:spPr>
           <a:xfrm>
-            <a:off x="548640" y="4626864"/>
+            <a:off x="548640" y="5285232"/>
             <a:ext cx="228600" cy="8000"/>
           </a:xfrm>
           <a:prstGeom prst="rect">
@@ -3820,14 +4165,14 @@
       </p:sp>
       <p:sp>
         <p:nvSpPr>
-          <p:cNvPr id="12" name="TextBox 11"/>
-          <p:cNvSpPr txBox="1"/>
-          <p:nvPr/>
-        </p:nvSpPr>
-        <p:spPr>
-          <a:xfrm>
-            <a:off x="868680" y="4480560"/>
-            <a:ext cx="4846320" cy="411480"/>
+          <p:cNvPr id="13" name="TextBox 12"/>
+          <p:cNvSpPr txBox="1"/>
+          <p:nvPr/>
+        </p:nvSpPr>
+        <p:spPr>
+          <a:xfrm>
+            <a:off x="868680" y="5138928"/>
+            <a:ext cx="7772400" cy="365760"/>
           </a:xfrm>
           <a:prstGeom prst="rect">
             <a:avLst/>
@@ -3859,13 +4204,13 @@
       </p:sp>
       <p:sp>
         <p:nvSpPr>
-          <p:cNvPr id="13" name="Rectangle 12"/>
+          <p:cNvPr id="14" name="Rectangle 13"/>
           <p:cNvSpPr/>
           <p:nvPr/>
         </p:nvSpPr>
         <p:spPr>
           <a:xfrm>
-            <a:off x="548640" y="5084064"/>
+            <a:off x="548640" y="5669280"/>
             <a:ext cx="228600" cy="8000"/>
           </a:xfrm>
           <a:prstGeom prst="rect">
@@ -3903,14 +4248,14 @@
       </p:sp>
       <p:sp>
         <p:nvSpPr>
-          <p:cNvPr id="14" name="TextBox 13"/>
-          <p:cNvSpPr txBox="1"/>
-          <p:nvPr/>
-        </p:nvSpPr>
-        <p:spPr>
-          <a:xfrm>
-            <a:off x="868680" y="4937760"/>
-            <a:ext cx="4846320" cy="411480"/>
+          <p:cNvPr id="15" name="TextBox 14"/>
+          <p:cNvSpPr txBox="1"/>
+          <p:nvPr/>
+        </p:nvSpPr>
+        <p:spPr>
+          <a:xfrm>
+            <a:off x="868680" y="5522976"/>
+            <a:ext cx="7772400" cy="365760"/>
           </a:xfrm>
           <a:prstGeom prst="rect">
             <a:avLst/>
@@ -3942,13 +4287,13 @@
       </p:sp>
       <p:sp>
         <p:nvSpPr>
-          <p:cNvPr id="15" name="Rectangle 14"/>
+          <p:cNvPr id="16" name="Rectangle 15"/>
           <p:cNvSpPr/>
           <p:nvPr/>
         </p:nvSpPr>
         <p:spPr>
           <a:xfrm>
-            <a:off x="548640" y="5541264"/>
+            <a:off x="548640" y="6053328"/>
             <a:ext cx="228600" cy="8000"/>
           </a:xfrm>
           <a:prstGeom prst="rect">
@@ -3986,14 +4331,14 @@
       </p:sp>
       <p:sp>
         <p:nvSpPr>
-          <p:cNvPr id="16" name="TextBox 15"/>
-          <p:cNvSpPr txBox="1"/>
-          <p:nvPr/>
-        </p:nvSpPr>
-        <p:spPr>
-          <a:xfrm>
-            <a:off x="868680" y="5394960"/>
-            <a:ext cx="4846320" cy="411480"/>
+          <p:cNvPr id="17" name="TextBox 16"/>
+          <p:cNvSpPr txBox="1"/>
+          <p:nvPr/>
+        </p:nvSpPr>
+        <p:spPr>
+          <a:xfrm>
+            <a:off x="868680" y="5907024"/>
+            <a:ext cx="7772400" cy="365760"/>
           </a:xfrm>
           <a:prstGeom prst="rect">
             <a:avLst/>
@@ -4025,7 +4370,7 @@
       </p:sp>
       <p:sp>
         <p:nvSpPr>
-          <p:cNvPr id="17" name="TextBox 16"/>
+          <p:cNvPr id="18" name="TextBox 17"/>
           <p:cNvSpPr txBox="1"/>
           <p:nvPr/>
         </p:nvSpPr>
@@ -4064,7 +4409,7 @@
       </p:sp>
       <p:sp>
         <p:nvSpPr>
-          <p:cNvPr id="18" name="TextBox 17"/>
+          <p:cNvPr id="19" name="TextBox 18"/>
           <p:cNvSpPr txBox="1"/>
           <p:nvPr/>
         </p:nvSpPr>
@@ -4180,7 +4525,7 @@
         <p:spPr>
           <a:xfrm>
             <a:off x="0" y="0"/>
-            <a:ext cx="6245352" cy="6858000"/>
+            <a:ext cx="12191695" cy="6858000"/>
           </a:xfrm>
           <a:prstGeom prst="rect">
             <a:avLst/>
@@ -4196,20 +4541,30 @@
         <p:spPr>
           <a:xfrm>
             <a:off x="0" y="0"/>
-            <a:ext cx="6245352" cy="6858000"/>
-          </a:xfrm>
-          <a:prstGeom prst="rect">
-            <a:avLst/>
-          </a:prstGeom>
-          <a:solidFill>
-            <a:srgbClr val="05070B">
-              <a:alpha val="35000"/>
-            </a:srgbClr>
-          </a:solidFill>
+            <a:ext cx="12191695" cy="6858000"/>
+          </a:xfrm>
+          <a:prstGeom prst="rect">
+            <a:avLst/>
+          </a:prstGeom>
           <a:ln>
             <a:noFill/>
           </a:ln>
           <a:effectLst/>
+          <a:gradFill flip="none" rotWithShape="1">
+            <a:gsLst>
+              <a:gs pos="0">
+                <a:srgbClr val="05070B">
+                  <a:alpha val="86000"/>
+                </a:srgbClr>
+              </a:gs>
+              <a:gs pos="100000">
+                <a:srgbClr val="05070B">
+                  <a:alpha val="12000"/>
+                </a:srgbClr>
+              </a:gs>
+            </a:gsLst>
+            <a:lin ang="0" scaled="0"/>
+          </a:gradFill>
         </p:spPr>
         <p:style>
           <a:lnRef idx="1">
@@ -4241,19 +4596,31 @@
         </p:nvSpPr>
         <p:spPr>
           <a:xfrm>
-            <a:off x="6245352" y="0"/>
-            <a:ext cx="5946343" cy="6858000"/>
-          </a:xfrm>
-          <a:prstGeom prst="rect">
-            <a:avLst/>
-          </a:prstGeom>
-          <a:solidFill>
-            <a:srgbClr val="05070B"/>
-          </a:solidFill>
+            <a:off x="0" y="4114800"/>
+            <a:ext cx="12191695" cy="2743200"/>
+          </a:xfrm>
+          <a:prstGeom prst="rect">
+            <a:avLst/>
+          </a:prstGeom>
           <a:ln>
             <a:noFill/>
           </a:ln>
           <a:effectLst/>
+          <a:gradFill flip="none" rotWithShape="1">
+            <a:gsLst>
+              <a:gs pos="0">
+                <a:srgbClr val="05070B">
+                  <a:alpha val="0"/>
+                </a:srgbClr>
+              </a:gs>
+              <a:gs pos="100000">
+                <a:srgbClr val="05070B">
+                  <a:alpha val="72000"/>
+                </a:srgbClr>
+              </a:gs>
+            </a:gsLst>
+            <a:lin ang="5400000" scaled="0"/>
+          </a:gradFill>
         </p:spPr>
         <p:style>
           <a:lnRef idx="1">
@@ -4285,7 +4652,7 @@
         </p:nvSpPr>
         <p:spPr>
           <a:xfrm>
-            <a:off x="6492240" y="640080"/>
+            <a:off x="548640" y="640080"/>
             <a:ext cx="548640" cy="8000"/>
           </a:xfrm>
           <a:prstGeom prst="rect">
@@ -4329,7 +4696,7 @@
         </p:nvSpPr>
         <p:spPr>
           <a:xfrm>
-            <a:off x="6492240" y="777240"/>
+            <a:off x="548640" y="777240"/>
             <a:ext cx="7315200" cy="274320"/>
           </a:xfrm>
           <a:prstGeom prst="rect">
@@ -4368,8 +4735,8 @@
         </p:nvSpPr>
         <p:spPr>
           <a:xfrm>
-            <a:off x="6492240" y="2011680"/>
-            <a:ext cx="5212080" cy="868680"/>
+            <a:off x="548640" y="2377440"/>
+            <a:ext cx="8686800" cy="960120"/>
           </a:xfrm>
           <a:prstGeom prst="rect">
             <a:avLst/>
@@ -4388,7 +4755,7 @@
               </a:lnSpc>
             </a:pPr>
             <a:r>
-              <a:rPr sz="4600" b="1" spc="-150">
+              <a:rPr sz="5800" b="1" spc="-180">
                 <a:solidFill>
                   <a:srgbClr val="FFFFFF"/>
                 </a:solidFill>
@@ -4407,8 +4774,8 @@
         </p:nvSpPr>
         <p:spPr>
           <a:xfrm>
-            <a:off x="6492240" y="2697480"/>
-            <a:ext cx="5212080" cy="868680"/>
+            <a:off x="548640" y="3246120"/>
+            <a:ext cx="10058400" cy="960120"/>
           </a:xfrm>
           <a:prstGeom prst="rect">
             <a:avLst/>
@@ -4427,7 +4794,7 @@
               </a:lnSpc>
             </a:pPr>
             <a:r>
-              <a:rPr sz="4600" b="1" spc="-150">
+              <a:rPr sz="5800" b="1" spc="-180">
                 <a:solidFill>
                   <a:srgbClr val="3AA0FF"/>
                 </a:solidFill>
@@ -4446,7 +4813,7 @@
         </p:nvSpPr>
         <p:spPr>
           <a:xfrm>
-            <a:off x="6492240" y="4169664"/>
+            <a:off x="548640" y="4901184"/>
             <a:ext cx="228600" cy="8000"/>
           </a:xfrm>
           <a:prstGeom prst="rect">
@@ -4490,8 +4857,8 @@
         </p:nvSpPr>
         <p:spPr>
           <a:xfrm>
-            <a:off x="6812280" y="4023360"/>
-            <a:ext cx="4846320" cy="411480"/>
+            <a:off x="868680" y="4754880"/>
+            <a:ext cx="7772400" cy="365760"/>
           </a:xfrm>
           <a:prstGeom prst="rect">
             <a:avLst/>
@@ -4529,7 +4896,7 @@
         </p:nvSpPr>
         <p:spPr>
           <a:xfrm>
-            <a:off x="6492240" y="4626864"/>
+            <a:off x="548640" y="5285232"/>
             <a:ext cx="228600" cy="8000"/>
           </a:xfrm>
           <a:prstGeom prst="rect">
@@ -4573,8 +4940,8 @@
         </p:nvSpPr>
         <p:spPr>
           <a:xfrm>
-            <a:off x="6812280" y="4480560"/>
-            <a:ext cx="4846320" cy="411480"/>
+            <a:off x="868680" y="5138928"/>
+            <a:ext cx="7772400" cy="365760"/>
           </a:xfrm>
           <a:prstGeom prst="rect">
             <a:avLst/>
@@ -4612,7 +4979,7 @@
         </p:nvSpPr>
         <p:spPr>
           <a:xfrm>
-            <a:off x="6492240" y="5084064"/>
+            <a:off x="548640" y="5669280"/>
             <a:ext cx="228600" cy="8000"/>
           </a:xfrm>
           <a:prstGeom prst="rect">
@@ -4656,8 +5023,8 @@
         </p:nvSpPr>
         <p:spPr>
           <a:xfrm>
-            <a:off x="6812280" y="4937760"/>
-            <a:ext cx="4846320" cy="411480"/>
+            <a:off x="868680" y="5522976"/>
+            <a:ext cx="7772400" cy="365760"/>
           </a:xfrm>
           <a:prstGeom prst="rect">
             <a:avLst/>
@@ -4695,7 +5062,7 @@
         </p:nvSpPr>
         <p:spPr>
           <a:xfrm>
-            <a:off x="6492240" y="5541264"/>
+            <a:off x="548640" y="6053328"/>
             <a:ext cx="228600" cy="8000"/>
           </a:xfrm>
           <a:prstGeom prst="rect">
@@ -4739,8 +5106,8 @@
         </p:nvSpPr>
         <p:spPr>
           <a:xfrm>
-            <a:off x="6812280" y="5394960"/>
-            <a:ext cx="4846320" cy="411480"/>
+            <a:off x="868680" y="5907024"/>
+            <a:ext cx="7772400" cy="365760"/>
           </a:xfrm>
           <a:prstGeom prst="rect">
             <a:avLst/>
@@ -4912,7 +5279,7 @@
       </p:sp>
       <p:pic>
         <p:nvPicPr>
-          <p:cNvPr id="3" name="Picture 2" descr="hero-port.jpg"/>
+          <p:cNvPr id="3" name="Picture 2" descr="port-cranes.jpg"/>
           <p:cNvPicPr>
             <a:picLocks noChangeAspect="1"/>
           </p:cNvPicPr>
@@ -4948,15 +5315,25 @@
           <a:prstGeom prst="rect">
             <a:avLst/>
           </a:prstGeom>
-          <a:solidFill>
-            <a:srgbClr val="05070B">
-              <a:alpha val="60000"/>
-            </a:srgbClr>
-          </a:solidFill>
           <a:ln>
             <a:noFill/>
           </a:ln>
           <a:effectLst/>
+          <a:gradFill flip="none" rotWithShape="1">
+            <a:gsLst>
+              <a:gs pos="0">
+                <a:srgbClr val="05070B">
+                  <a:alpha val="86000"/>
+                </a:srgbClr>
+              </a:gs>
+              <a:gs pos="100000">
+                <a:srgbClr val="05070B">
+                  <a:alpha val="12000"/>
+                </a:srgbClr>
+              </a:gs>
+            </a:gsLst>
+            <a:lin ang="0" scaled="0"/>
+          </a:gradFill>
         </p:spPr>
         <p:style>
           <a:lnRef idx="1">
@@ -4983,6 +5360,62 @@
       <p:sp>
         <p:nvSpPr>
           <p:cNvPr id="5" name="Rectangle 4"/>
+          <p:cNvSpPr/>
+          <p:nvPr/>
+        </p:nvSpPr>
+        <p:spPr>
+          <a:xfrm>
+            <a:off x="0" y="4114800"/>
+            <a:ext cx="12191695" cy="2743200"/>
+          </a:xfrm>
+          <a:prstGeom prst="rect">
+            <a:avLst/>
+          </a:prstGeom>
+          <a:ln>
+            <a:noFill/>
+          </a:ln>
+          <a:effectLst/>
+          <a:gradFill flip="none" rotWithShape="1">
+            <a:gsLst>
+              <a:gs pos="0">
+                <a:srgbClr val="05070B">
+                  <a:alpha val="0"/>
+                </a:srgbClr>
+              </a:gs>
+              <a:gs pos="100000">
+                <a:srgbClr val="05070B">
+                  <a:alpha val="75000"/>
+                </a:srgbClr>
+              </a:gs>
+            </a:gsLst>
+            <a:lin ang="5400000" scaled="0"/>
+          </a:gradFill>
+        </p:spPr>
+        <p:style>
+          <a:lnRef idx="1">
+            <a:schemeClr val="accent1"/>
+          </a:lnRef>
+          <a:fillRef idx="3">
+            <a:schemeClr val="accent1"/>
+          </a:fillRef>
+          <a:effectRef idx="2">
+            <a:schemeClr val="accent1"/>
+          </a:effectRef>
+          <a:fontRef idx="minor">
+            <a:schemeClr val="lt1"/>
+          </a:fontRef>
+        </p:style>
+        <p:txBody>
+          <a:bodyPr rtlCol="0" anchor="ctr"/>
+          <a:lstStyle/>
+          <a:p>
+            <a:pPr algn="ctr"/>
+          </a:p>
+        </p:txBody>
+      </p:sp>
+      <p:sp>
+        <p:nvSpPr>
+          <p:cNvPr id="6" name="Rectangle 5"/>
           <p:cNvSpPr/>
           <p:nvPr/>
         </p:nvSpPr>
@@ -5026,7 +5459,7 @@
       </p:sp>
       <p:sp>
         <p:nvSpPr>
-          <p:cNvPr id="6" name="TextBox 5"/>
+          <p:cNvPr id="7" name="TextBox 6"/>
           <p:cNvSpPr txBox="1"/>
           <p:nvPr/>
         </p:nvSpPr>
@@ -5058,21 +5491,21 @@
                 </a:solidFill>
                 <a:latin typeface="Helvetica Neue"/>
               </a:rPr>
-              <a:t>MODE · LAND TRANSPORT</a:t>
-            </a:r>
-          </a:p>
-        </p:txBody>
-      </p:sp>
-      <p:sp>
-        <p:nvSpPr>
-          <p:cNvPr id="7" name="TextBox 6"/>
+              <a:t>MODE · LAND &amp; CROSS-BORDER TRANSPORT</a:t>
+            </a:r>
+          </a:p>
+        </p:txBody>
+      </p:sp>
+      <p:sp>
+        <p:nvSpPr>
+          <p:cNvPr id="8" name="TextBox 7"/>
           <p:cNvSpPr txBox="1"/>
           <p:nvPr/>
         </p:nvSpPr>
         <p:spPr>
           <a:xfrm>
             <a:off x="548640" y="2377440"/>
-            <a:ext cx="10058400" cy="914400"/>
+            <a:ext cx="10058400" cy="960120"/>
           </a:xfrm>
           <a:prstGeom prst="rect">
             <a:avLst/>
@@ -5104,14 +5537,14 @@
       </p:sp>
       <p:sp>
         <p:nvSpPr>
-          <p:cNvPr id="8" name="TextBox 7"/>
-          <p:cNvSpPr txBox="1"/>
-          <p:nvPr/>
-        </p:nvSpPr>
-        <p:spPr>
-          <a:xfrm>
-            <a:off x="548640" y="3154680"/>
-            <a:ext cx="10058400" cy="914400"/>
+          <p:cNvPr id="9" name="TextBox 8"/>
+          <p:cNvSpPr txBox="1"/>
+          <p:nvPr/>
+        </p:nvSpPr>
+        <p:spPr>
+          <a:xfrm>
+            <a:off x="548640" y="3246120"/>
+            <a:ext cx="10058400" cy="960120"/>
           </a:xfrm>
           <a:prstGeom prst="rect">
             <a:avLst/>
@@ -5143,13 +5576,13 @@
       </p:sp>
       <p:sp>
         <p:nvSpPr>
-          <p:cNvPr id="9" name="Rectangle 8"/>
+          <p:cNvPr id="10" name="Rectangle 9"/>
           <p:cNvSpPr/>
           <p:nvPr/>
         </p:nvSpPr>
         <p:spPr>
           <a:xfrm>
-            <a:off x="548640" y="4764024"/>
+            <a:off x="548640" y="4901184"/>
             <a:ext cx="228600" cy="8000"/>
           </a:xfrm>
           <a:prstGeom prst="rect">
@@ -5187,14 +5620,14 @@
       </p:sp>
       <p:sp>
         <p:nvSpPr>
-          <p:cNvPr id="10" name="TextBox 9"/>
-          <p:cNvSpPr txBox="1"/>
-          <p:nvPr/>
-        </p:nvSpPr>
-        <p:spPr>
-          <a:xfrm>
-            <a:off x="868680" y="4617720"/>
-            <a:ext cx="10058400" cy="411480"/>
+          <p:cNvPr id="11" name="TextBox 10"/>
+          <p:cNvSpPr txBox="1"/>
+          <p:nvPr/>
+        </p:nvSpPr>
+        <p:spPr>
+          <a:xfrm>
+            <a:off x="868680" y="4754880"/>
+            <a:ext cx="10058400" cy="365760"/>
           </a:xfrm>
           <a:prstGeom prst="rect">
             <a:avLst/>
@@ -5213,9 +5646,9 @@
               </a:lnSpc>
             </a:pPr>
             <a:r>
-              <a:rPr sz="1300" b="0">
-                <a:solidFill>
-                  <a:srgbClr val="FFFFFF"/>
+              <a:rPr sz="1200" b="0">
+                <a:solidFill>
+                  <a:srgbClr val="BCC3CF"/>
                 </a:solidFill>
                 <a:latin typeface="Helvetica Neue"/>
               </a:rPr>
@@ -5226,13 +5659,13 @@
       </p:sp>
       <p:sp>
         <p:nvSpPr>
-          <p:cNvPr id="11" name="Rectangle 10"/>
+          <p:cNvPr id="12" name="Rectangle 11"/>
           <p:cNvSpPr/>
           <p:nvPr/>
         </p:nvSpPr>
         <p:spPr>
           <a:xfrm>
-            <a:off x="548640" y="5129784"/>
+            <a:off x="548640" y="5285232"/>
             <a:ext cx="228600" cy="8000"/>
           </a:xfrm>
           <a:prstGeom prst="rect">
@@ -5270,14 +5703,14 @@
       </p:sp>
       <p:sp>
         <p:nvSpPr>
-          <p:cNvPr id="12" name="TextBox 11"/>
-          <p:cNvSpPr txBox="1"/>
-          <p:nvPr/>
-        </p:nvSpPr>
-        <p:spPr>
-          <a:xfrm>
-            <a:off x="868680" y="4983480"/>
-            <a:ext cx="10058400" cy="411480"/>
+          <p:cNvPr id="13" name="TextBox 12"/>
+          <p:cNvSpPr txBox="1"/>
+          <p:nvPr/>
+        </p:nvSpPr>
+        <p:spPr>
+          <a:xfrm>
+            <a:off x="868680" y="5138928"/>
+            <a:ext cx="10058400" cy="365760"/>
           </a:xfrm>
           <a:prstGeom prst="rect">
             <a:avLst/>
@@ -5296,9 +5729,9 @@
               </a:lnSpc>
             </a:pPr>
             <a:r>
-              <a:rPr sz="1300" b="0">
-                <a:solidFill>
-                  <a:srgbClr val="FFFFFF"/>
+              <a:rPr sz="1200" b="0">
+                <a:solidFill>
+                  <a:srgbClr val="BCC3CF"/>
                 </a:solidFill>
                 <a:latin typeface="Helvetica Neue"/>
               </a:rPr>
@@ -5309,13 +5742,13 @@
       </p:sp>
       <p:sp>
         <p:nvSpPr>
-          <p:cNvPr id="13" name="Rectangle 12"/>
+          <p:cNvPr id="14" name="Rectangle 13"/>
           <p:cNvSpPr/>
           <p:nvPr/>
         </p:nvSpPr>
         <p:spPr>
           <a:xfrm>
-            <a:off x="548640" y="5495544"/>
+            <a:off x="548640" y="5669280"/>
             <a:ext cx="228600" cy="8000"/>
           </a:xfrm>
           <a:prstGeom prst="rect">
@@ -5353,14 +5786,14 @@
       </p:sp>
       <p:sp>
         <p:nvSpPr>
-          <p:cNvPr id="14" name="TextBox 13"/>
-          <p:cNvSpPr txBox="1"/>
-          <p:nvPr/>
-        </p:nvSpPr>
-        <p:spPr>
-          <a:xfrm>
-            <a:off x="868680" y="5349240"/>
-            <a:ext cx="10058400" cy="411480"/>
+          <p:cNvPr id="15" name="TextBox 14"/>
+          <p:cNvSpPr txBox="1"/>
+          <p:nvPr/>
+        </p:nvSpPr>
+        <p:spPr>
+          <a:xfrm>
+            <a:off x="868680" y="5522976"/>
+            <a:ext cx="10058400" cy="365760"/>
           </a:xfrm>
           <a:prstGeom prst="rect">
             <a:avLst/>
@@ -5379,9 +5812,9 @@
               </a:lnSpc>
             </a:pPr>
             <a:r>
-              <a:rPr sz="1300" b="0">
-                <a:solidFill>
-                  <a:srgbClr val="FFFFFF"/>
+              <a:rPr sz="1200" b="0">
+                <a:solidFill>
+                  <a:srgbClr val="BCC3CF"/>
                 </a:solidFill>
                 <a:latin typeface="Helvetica Neue"/>
               </a:rPr>
@@ -5392,13 +5825,13 @@
       </p:sp>
       <p:sp>
         <p:nvSpPr>
-          <p:cNvPr id="15" name="Rectangle 14"/>
+          <p:cNvPr id="16" name="Rectangle 15"/>
           <p:cNvSpPr/>
           <p:nvPr/>
         </p:nvSpPr>
         <p:spPr>
           <a:xfrm>
-            <a:off x="548640" y="5861304"/>
+            <a:off x="548640" y="6053328"/>
             <a:ext cx="228600" cy="8000"/>
           </a:xfrm>
           <a:prstGeom prst="rect">
@@ -5436,14 +5869,14 @@
       </p:sp>
       <p:sp>
         <p:nvSpPr>
-          <p:cNvPr id="16" name="TextBox 15"/>
-          <p:cNvSpPr txBox="1"/>
-          <p:nvPr/>
-        </p:nvSpPr>
-        <p:spPr>
-          <a:xfrm>
-            <a:off x="868680" y="5715000"/>
-            <a:ext cx="10058400" cy="411480"/>
+          <p:cNvPr id="17" name="TextBox 16"/>
+          <p:cNvSpPr txBox="1"/>
+          <p:nvPr/>
+        </p:nvSpPr>
+        <p:spPr>
+          <a:xfrm>
+            <a:off x="868680" y="5907024"/>
+            <a:ext cx="10058400" cy="365760"/>
           </a:xfrm>
           <a:prstGeom prst="rect">
             <a:avLst/>
@@ -5462,9 +5895,9 @@
               </a:lnSpc>
             </a:pPr>
             <a:r>
-              <a:rPr sz="1300" b="0">
-                <a:solidFill>
-                  <a:srgbClr val="FFFFFF"/>
+              <a:rPr sz="1200" b="0">
+                <a:solidFill>
+                  <a:srgbClr val="BCC3CF"/>
                 </a:solidFill>
                 <a:latin typeface="Helvetica Neue"/>
               </a:rPr>
@@ -5475,7 +5908,7 @@
       </p:sp>
       <p:sp>
         <p:nvSpPr>
-          <p:cNvPr id="17" name="TextBox 16"/>
+          <p:cNvPr id="18" name="TextBox 17"/>
           <p:cNvSpPr txBox="1"/>
           <p:nvPr/>
         </p:nvSpPr>
@@ -5514,7 +5947,7 @@
       </p:sp>
       <p:sp>
         <p:nvSpPr>
-          <p:cNvPr id="18" name="TextBox 17"/>
+          <p:cNvPr id="19" name="TextBox 18"/>
           <p:cNvSpPr txBox="1"/>
           <p:nvPr/>
         </p:nvSpPr>
@@ -14177,9 +14610,145 @@
           </a:p>
         </p:txBody>
       </p:sp>
-      <p:sp>
-        <p:nvSpPr>
-          <p:cNvPr id="3" name="Rectangle 2"/>
+      <p:pic>
+        <p:nvPicPr>
+          <p:cNvPr id="3" name="Picture 2" descr="customs-inspection.jpg"/>
+          <p:cNvPicPr>
+            <a:picLocks noChangeAspect="1"/>
+          </p:cNvPicPr>
+          <p:nvPr/>
+        </p:nvPicPr>
+        <p:blipFill>
+          <a:blip r:embed="rId2"/>
+          <a:stretch>
+            <a:fillRect/>
+          </a:stretch>
+        </p:blipFill>
+        <p:spPr>
+          <a:xfrm>
+            <a:off x="0" y="0"/>
+            <a:ext cx="12191695" cy="6858000"/>
+          </a:xfrm>
+          <a:prstGeom prst="rect">
+            <a:avLst/>
+          </a:prstGeom>
+        </p:spPr>
+      </p:pic>
+      <p:sp>
+        <p:nvSpPr>
+          <p:cNvPr id="4" name="Rectangle 3"/>
+          <p:cNvSpPr/>
+          <p:nvPr/>
+        </p:nvSpPr>
+        <p:spPr>
+          <a:xfrm>
+            <a:off x="0" y="0"/>
+            <a:ext cx="12191695" cy="6858000"/>
+          </a:xfrm>
+          <a:prstGeom prst="rect">
+            <a:avLst/>
+          </a:prstGeom>
+          <a:ln>
+            <a:noFill/>
+          </a:ln>
+          <a:effectLst/>
+          <a:gradFill flip="none" rotWithShape="1">
+            <a:gsLst>
+              <a:gs pos="0">
+                <a:srgbClr val="05070B">
+                  <a:alpha val="88000"/>
+                </a:srgbClr>
+              </a:gs>
+              <a:gs pos="100000">
+                <a:srgbClr val="05070B">
+                  <a:alpha val="8000"/>
+                </a:srgbClr>
+              </a:gs>
+            </a:gsLst>
+            <a:lin ang="0" scaled="0"/>
+          </a:gradFill>
+        </p:spPr>
+        <p:style>
+          <a:lnRef idx="1">
+            <a:schemeClr val="accent1"/>
+          </a:lnRef>
+          <a:fillRef idx="3">
+            <a:schemeClr val="accent1"/>
+          </a:fillRef>
+          <a:effectRef idx="2">
+            <a:schemeClr val="accent1"/>
+          </a:effectRef>
+          <a:fontRef idx="minor">
+            <a:schemeClr val="lt1"/>
+          </a:fontRef>
+        </p:style>
+        <p:txBody>
+          <a:bodyPr rtlCol="0" anchor="ctr"/>
+          <a:lstStyle/>
+          <a:p>
+            <a:pPr algn="ctr"/>
+          </a:p>
+        </p:txBody>
+      </p:sp>
+      <p:sp>
+        <p:nvSpPr>
+          <p:cNvPr id="5" name="Rectangle 4"/>
+          <p:cNvSpPr/>
+          <p:nvPr/>
+        </p:nvSpPr>
+        <p:spPr>
+          <a:xfrm>
+            <a:off x="0" y="4114800"/>
+            <a:ext cx="12191695" cy="2743200"/>
+          </a:xfrm>
+          <a:prstGeom prst="rect">
+            <a:avLst/>
+          </a:prstGeom>
+          <a:ln>
+            <a:noFill/>
+          </a:ln>
+          <a:effectLst/>
+          <a:gradFill flip="none" rotWithShape="1">
+            <a:gsLst>
+              <a:gs pos="0">
+                <a:srgbClr val="05070B">
+                  <a:alpha val="0"/>
+                </a:srgbClr>
+              </a:gs>
+              <a:gs pos="100000">
+                <a:srgbClr val="05070B">
+                  <a:alpha val="70000"/>
+                </a:srgbClr>
+              </a:gs>
+            </a:gsLst>
+            <a:lin ang="5400000" scaled="0"/>
+          </a:gradFill>
+        </p:spPr>
+        <p:style>
+          <a:lnRef idx="1">
+            <a:schemeClr val="accent1"/>
+          </a:lnRef>
+          <a:fillRef idx="3">
+            <a:schemeClr val="accent1"/>
+          </a:fillRef>
+          <a:effectRef idx="2">
+            <a:schemeClr val="accent1"/>
+          </a:effectRef>
+          <a:fontRef idx="minor">
+            <a:schemeClr val="lt1"/>
+          </a:fontRef>
+        </p:style>
+        <p:txBody>
+          <a:bodyPr rtlCol="0" anchor="ctr"/>
+          <a:lstStyle/>
+          <a:p>
+            <a:pPr algn="ctr"/>
+          </a:p>
+        </p:txBody>
+      </p:sp>
+      <p:sp>
+        <p:nvSpPr>
+          <p:cNvPr id="6" name="Rectangle 5"/>
           <p:cNvSpPr/>
           <p:nvPr/>
         </p:nvSpPr>
@@ -14223,7 +14792,7 @@
       </p:sp>
       <p:sp>
         <p:nvSpPr>
-          <p:cNvPr id="4" name="TextBox 3"/>
+          <p:cNvPr id="7" name="TextBox 6"/>
           <p:cNvSpPr txBox="1"/>
           <p:nvPr/>
         </p:nvSpPr>
@@ -14260,59 +14829,35 @@
           </a:p>
         </p:txBody>
       </p:sp>
-      <p:pic>
-        <p:nvPicPr>
-          <p:cNvPr id="5" name="Picture 4" descr="customs-inspection.jpg"/>
-          <p:cNvPicPr>
-            <a:picLocks noChangeAspect="1"/>
-          </p:cNvPicPr>
-          <p:nvPr/>
-        </p:nvPicPr>
-        <p:blipFill>
-          <a:blip r:embed="rId2"/>
-          <a:stretch>
-            <a:fillRect/>
-          </a:stretch>
-        </p:blipFill>
-        <p:spPr>
-          <a:xfrm>
-            <a:off x="548640" y="1828800"/>
-            <a:ext cx="5120640" cy="4114800"/>
-          </a:xfrm>
-          <a:prstGeom prst="rect">
-            <a:avLst/>
-          </a:prstGeom>
-        </p:spPr>
-      </p:pic>
-      <p:sp>
-        <p:nvSpPr>
-          <p:cNvPr id="6" name="TextBox 5"/>
-          <p:cNvSpPr txBox="1"/>
-          <p:nvPr/>
-        </p:nvSpPr>
-        <p:spPr>
-          <a:xfrm>
-            <a:off x="6035040" y="1737360"/>
-            <a:ext cx="5943600" cy="868680"/>
-          </a:xfrm>
-          <a:prstGeom prst="rect">
-            <a:avLst/>
-          </a:prstGeom>
-          <a:noFill/>
-        </p:spPr>
-        <p:txBody>
-          <a:bodyPr wrap="square" lIns="0" rIns="0" tIns="0" bIns="0" anchor="t">
-            <a:spAutoFit/>
-          </a:bodyPr>
-          <a:lstStyle/>
-          <a:p>
-            <a:pPr algn="l">
-              <a:lnSpc>
-                <a:spcPct val="105000"/>
-              </a:lnSpc>
-            </a:pPr>
-            <a:r>
-              <a:rPr sz="4600" b="1" spc="-150">
+      <p:sp>
+        <p:nvSpPr>
+          <p:cNvPr id="8" name="TextBox 7"/>
+          <p:cNvSpPr txBox="1"/>
+          <p:nvPr/>
+        </p:nvSpPr>
+        <p:spPr>
+          <a:xfrm>
+            <a:off x="548640" y="2286000"/>
+            <a:ext cx="7772400" cy="960120"/>
+          </a:xfrm>
+          <a:prstGeom prst="rect">
+            <a:avLst/>
+          </a:prstGeom>
+          <a:noFill/>
+        </p:spPr>
+        <p:txBody>
+          <a:bodyPr wrap="square" lIns="0" rIns="0" tIns="0" bIns="0" anchor="t">
+            <a:spAutoFit/>
+          </a:bodyPr>
+          <a:lstStyle/>
+          <a:p>
+            <a:pPr algn="l">
+              <a:lnSpc>
+                <a:spcPct val="100000"/>
+              </a:lnSpc>
+            </a:pPr>
+            <a:r>
+              <a:rPr sz="5800" b="1" spc="-180">
                 <a:solidFill>
                   <a:srgbClr val="FFFFFF"/>
                 </a:solidFill>
@@ -14325,33 +14870,33 @@
       </p:sp>
       <p:sp>
         <p:nvSpPr>
-          <p:cNvPr id="7" name="TextBox 6"/>
-          <p:cNvSpPr txBox="1"/>
-          <p:nvPr/>
-        </p:nvSpPr>
-        <p:spPr>
-          <a:xfrm>
-            <a:off x="6035040" y="2423160"/>
-            <a:ext cx="5943600" cy="868680"/>
-          </a:xfrm>
-          <a:prstGeom prst="rect">
-            <a:avLst/>
-          </a:prstGeom>
-          <a:noFill/>
-        </p:spPr>
-        <p:txBody>
-          <a:bodyPr wrap="square" lIns="0" rIns="0" tIns="0" bIns="0" anchor="t">
-            <a:spAutoFit/>
-          </a:bodyPr>
-          <a:lstStyle/>
-          <a:p>
-            <a:pPr algn="l">
-              <a:lnSpc>
-                <a:spcPct val="105000"/>
-              </a:lnSpc>
-            </a:pPr>
-            <a:r>
-              <a:rPr sz="4600" b="1" spc="-150">
+          <p:cNvPr id="9" name="TextBox 8"/>
+          <p:cNvSpPr txBox="1"/>
+          <p:nvPr/>
+        </p:nvSpPr>
+        <p:spPr>
+          <a:xfrm>
+            <a:off x="548640" y="3154680"/>
+            <a:ext cx="7772400" cy="960120"/>
+          </a:xfrm>
+          <a:prstGeom prst="rect">
+            <a:avLst/>
+          </a:prstGeom>
+          <a:noFill/>
+        </p:spPr>
+        <p:txBody>
+          <a:bodyPr wrap="square" lIns="0" rIns="0" tIns="0" bIns="0" anchor="t">
+            <a:spAutoFit/>
+          </a:bodyPr>
+          <a:lstStyle/>
+          <a:p>
+            <a:pPr algn="l">
+              <a:lnSpc>
+                <a:spcPct val="100000"/>
+              </a:lnSpc>
+            </a:pPr>
+            <a:r>
+              <a:rPr sz="5800" b="1" spc="-180">
                 <a:solidFill>
                   <a:srgbClr val="3AA0FF"/>
                 </a:solidFill>
@@ -14364,14 +14909,14 @@
       </p:sp>
       <p:sp>
         <p:nvSpPr>
-          <p:cNvPr id="8" name="TextBox 7"/>
-          <p:cNvSpPr txBox="1"/>
-          <p:nvPr/>
-        </p:nvSpPr>
-        <p:spPr>
-          <a:xfrm>
-            <a:off x="6035040" y="3657600"/>
-            <a:ext cx="5669280" cy="1828800"/>
+          <p:cNvPr id="10" name="TextBox 9"/>
+          <p:cNvSpPr txBox="1"/>
+          <p:nvPr/>
+        </p:nvSpPr>
+        <p:spPr>
+          <a:xfrm>
+            <a:off x="548640" y="4754880"/>
+            <a:ext cx="6858000" cy="1371600"/>
           </a:xfrm>
           <a:prstGeom prst="rect">
             <a:avLst/>
@@ -14396,14 +14941,14 @@
                 </a:solidFill>
                 <a:latin typeface="Helvetica Neue"/>
               </a:rPr>
-              <a:t>Licensed brokers handle the full lifecycle of an import or export entry — from pre-arrival filing to post-entry reconciliation. Proactive duty-and-penalty avoidance built into every clearance.</a:t>
-            </a:r>
-          </a:p>
-        </p:txBody>
-      </p:sp>
-      <p:sp>
-        <p:nvSpPr>
-          <p:cNvPr id="9" name="TextBox 8"/>
+              <a:t>Licensed brokers handle the full lifecycle of an import or export entry — from pre-arrival filing to post-entry reconciliation. Proactive duty-and-penalty avoidance, built into every clearance.</a:t>
+            </a:r>
+          </a:p>
+        </p:txBody>
+      </p:sp>
+      <p:sp>
+        <p:nvSpPr>
+          <p:cNvPr id="11" name="TextBox 10"/>
           <p:cNvSpPr txBox="1"/>
           <p:nvPr/>
         </p:nvSpPr>
@@ -14442,7 +14987,7 @@
       </p:sp>
       <p:sp>
         <p:nvSpPr>
-          <p:cNvPr id="10" name="TextBox 9"/>
+          <p:cNvPr id="12" name="TextBox 11"/>
           <p:cNvSpPr txBox="1"/>
           <p:nvPr/>
         </p:nvSpPr>
@@ -16481,15 +17026,25 @@
           <a:prstGeom prst="rect">
             <a:avLst/>
           </a:prstGeom>
-          <a:solidFill>
-            <a:srgbClr val="05070B">
-              <a:alpha val="68000"/>
-            </a:srgbClr>
-          </a:solidFill>
           <a:ln>
             <a:noFill/>
           </a:ln>
           <a:effectLst/>
+          <a:gradFill flip="none" rotWithShape="1">
+            <a:gsLst>
+              <a:gs pos="0">
+                <a:srgbClr val="05070B">
+                  <a:alpha val="82000"/>
+                </a:srgbClr>
+              </a:gs>
+              <a:gs pos="100000">
+                <a:srgbClr val="05070B">
+                  <a:alpha val="20000"/>
+                </a:srgbClr>
+              </a:gs>
+            </a:gsLst>
+            <a:lin ang="0" scaled="0"/>
+          </a:gradFill>
         </p:spPr>
         <p:style>
           <a:lnRef idx="1">
@@ -16516,6 +17071,62 @@
       <p:sp>
         <p:nvSpPr>
           <p:cNvPr id="5" name="Rectangle 4"/>
+          <p:cNvSpPr/>
+          <p:nvPr/>
+        </p:nvSpPr>
+        <p:spPr>
+          <a:xfrm>
+            <a:off x="0" y="4114800"/>
+            <a:ext cx="12191695" cy="2743200"/>
+          </a:xfrm>
+          <a:prstGeom prst="rect">
+            <a:avLst/>
+          </a:prstGeom>
+          <a:ln>
+            <a:noFill/>
+          </a:ln>
+          <a:effectLst/>
+          <a:gradFill flip="none" rotWithShape="1">
+            <a:gsLst>
+              <a:gs pos="0">
+                <a:srgbClr val="05070B">
+                  <a:alpha val="0"/>
+                </a:srgbClr>
+              </a:gs>
+              <a:gs pos="100000">
+                <a:srgbClr val="05070B">
+                  <a:alpha val="75000"/>
+                </a:srgbClr>
+              </a:gs>
+            </a:gsLst>
+            <a:lin ang="5400000" scaled="0"/>
+          </a:gradFill>
+        </p:spPr>
+        <p:style>
+          <a:lnRef idx="1">
+            <a:schemeClr val="accent1"/>
+          </a:lnRef>
+          <a:fillRef idx="3">
+            <a:schemeClr val="accent1"/>
+          </a:fillRef>
+          <a:effectRef idx="2">
+            <a:schemeClr val="accent1"/>
+          </a:effectRef>
+          <a:fontRef idx="minor">
+            <a:schemeClr val="lt1"/>
+          </a:fontRef>
+        </p:style>
+        <p:txBody>
+          <a:bodyPr rtlCol="0" anchor="ctr"/>
+          <a:lstStyle/>
+          <a:p>
+            <a:pPr algn="ctr"/>
+          </a:p>
+        </p:txBody>
+      </p:sp>
+      <p:sp>
+        <p:nvSpPr>
+          <p:cNvPr id="6" name="Rectangle 5"/>
           <p:cNvSpPr/>
           <p:nvPr/>
         </p:nvSpPr>
@@ -16559,7 +17170,7 @@
       </p:sp>
       <p:sp>
         <p:nvSpPr>
-          <p:cNvPr id="6" name="TextBox 5"/>
+          <p:cNvPr id="7" name="TextBox 6"/>
           <p:cNvSpPr txBox="1"/>
           <p:nvPr/>
         </p:nvSpPr>
@@ -16598,14 +17209,14 @@
       </p:sp>
       <p:sp>
         <p:nvSpPr>
-          <p:cNvPr id="7" name="TextBox 6"/>
-          <p:cNvSpPr txBox="1"/>
-          <p:nvPr/>
-        </p:nvSpPr>
-        <p:spPr>
-          <a:xfrm>
-            <a:off x="548640" y="2743200"/>
-            <a:ext cx="10972800" cy="914400"/>
+          <p:cNvPr id="8" name="TextBox 7"/>
+          <p:cNvSpPr txBox="1"/>
+          <p:nvPr/>
+        </p:nvSpPr>
+        <p:spPr>
+          <a:xfrm>
+            <a:off x="548640" y="2377440"/>
+            <a:ext cx="10058400" cy="960120"/>
           </a:xfrm>
           <a:prstGeom prst="rect">
             <a:avLst/>
@@ -16624,7 +17235,7 @@
               </a:lnSpc>
             </a:pPr>
             <a:r>
-              <a:rPr sz="5400" b="1" spc="-170">
+              <a:rPr sz="5800" b="1" spc="-180">
                 <a:solidFill>
                   <a:srgbClr val="FFFFFF"/>
                 </a:solidFill>
@@ -16637,14 +17248,14 @@
       </p:sp>
       <p:sp>
         <p:nvSpPr>
-          <p:cNvPr id="8" name="TextBox 7"/>
-          <p:cNvSpPr txBox="1"/>
-          <p:nvPr/>
-        </p:nvSpPr>
-        <p:spPr>
-          <a:xfrm>
-            <a:off x="548640" y="3520440"/>
-            <a:ext cx="10972800" cy="914400"/>
+          <p:cNvPr id="9" name="TextBox 8"/>
+          <p:cNvSpPr txBox="1"/>
+          <p:nvPr/>
+        </p:nvSpPr>
+        <p:spPr>
+          <a:xfrm>
+            <a:off x="548640" y="3246120"/>
+            <a:ext cx="10972800" cy="960120"/>
           </a:xfrm>
           <a:prstGeom prst="rect">
             <a:avLst/>
@@ -16663,7 +17274,7 @@
               </a:lnSpc>
             </a:pPr>
             <a:r>
-              <a:rPr sz="5400" b="1" spc="-170">
+              <a:rPr sz="5800" b="1" spc="-180">
                 <a:solidFill>
                   <a:srgbClr val="3AA0FF"/>
                 </a:solidFill>
@@ -16676,13 +17287,13 @@
       </p:sp>
       <p:sp>
         <p:nvSpPr>
-          <p:cNvPr id="9" name="TextBox 8"/>
-          <p:cNvSpPr txBox="1"/>
-          <p:nvPr/>
-        </p:nvSpPr>
-        <p:spPr>
-          <a:xfrm>
-            <a:off x="548640" y="4937760"/>
+          <p:cNvPr id="10" name="TextBox 9"/>
+          <p:cNvSpPr txBox="1"/>
+          <p:nvPr/>
+        </p:nvSpPr>
+        <p:spPr>
+          <a:xfrm>
+            <a:off x="548640" y="4846320"/>
             <a:ext cx="8229600" cy="1371600"/>
           </a:xfrm>
           <a:prstGeom prst="rect">
@@ -16708,14 +17319,14 @@
                 </a:solidFill>
                 <a:latin typeface="Helvetica Neue"/>
               </a:rPr>
-              <a:t>We coordinate the physical movement of your goods across the U.S.–Mexico border and beyond — trucking, ocean, and air freight under one accountable team. One invoice. No handoff gaps.</a:t>
-            </a:r>
-          </a:p>
-        </p:txBody>
-      </p:sp>
-      <p:sp>
-        <p:nvSpPr>
-          <p:cNvPr id="10" name="TextBox 9"/>
+              <a:t>Physical movement of your goods across the U.S.–Mexico border and beyond — trucking, ocean, and air freight under one accountable team. One invoice. No handoff gaps.</a:t>
+            </a:r>
+          </a:p>
+        </p:txBody>
+      </p:sp>
+      <p:sp>
+        <p:nvSpPr>
+          <p:cNvPr id="11" name="TextBox 10"/>
           <p:cNvSpPr txBox="1"/>
           <p:nvPr/>
         </p:nvSpPr>
@@ -16754,7 +17365,7 @@
       </p:sp>
       <p:sp>
         <p:nvSpPr>
-          <p:cNvPr id="11" name="TextBox 10"/>
+          <p:cNvPr id="12" name="TextBox 11"/>
           <p:cNvSpPr txBox="1"/>
           <p:nvPr/>
         </p:nvSpPr>

</xml_diff>

<commit_message>
Deck v3: official client logos on slide 17 + cinematic logistics photos on slides 7/9/10/11/12
Co-Authored-By: Claude Opus 4.7 (1M context) <noreply@anthropic.com>
</commit_message>
<xml_diff>
--- a/public/presentations/ISN-Customs-Brokerage-Deck.pptx
+++ b/public/presentations/ISN-Customs-Brokerage-Deck.pptx
@@ -3741,14 +3741,15 @@
       </p:sp>
       <p:pic>
         <p:nvPicPr>
-          <p:cNvPr id="3" name="Picture 2" descr="air-cargo.jpg"/>
+          <p:cNvPr id="20" name="Picture 19" descr="04-air-cargo.jpg"/>
           <p:cNvPicPr>
             <a:picLocks noChangeAspect="1"/>
           </p:cNvPicPr>
           <p:nvPr/>
         </p:nvPicPr>
         <p:blipFill>
-          <a:blip r:embed="rId2"/>
+          <a:blip r:embed="rId3"/>
+          <a:srcRect t="35962" b="35962"/>
           <a:stretch>
             <a:fillRect/>
           </a:stretch>
@@ -4510,14 +4511,15 @@
       </p:sp>
       <p:pic>
         <p:nvPicPr>
-          <p:cNvPr id="3" name="Picture 2" descr="port-aerial.jpg"/>
+          <p:cNvPr id="20" name="Picture 19" descr="03-container-ship.jpg"/>
           <p:cNvPicPr>
             <a:picLocks noChangeAspect="1"/>
           </p:cNvPicPr>
           <p:nvPr/>
         </p:nvPicPr>
         <p:blipFill>
-          <a:blip r:embed="rId2"/>
+          <a:blip r:embed="rId3"/>
+          <a:srcRect t="35962" b="35962"/>
           <a:stretch>
             <a:fillRect/>
           </a:stretch>
@@ -5279,14 +5281,15 @@
       </p:sp>
       <p:pic>
         <p:nvPicPr>
-          <p:cNvPr id="3" name="Picture 2" descr="port-cranes.jpg"/>
+          <p:cNvPr id="20" name="Picture 19" descr="02-highway-truck.jpg"/>
           <p:cNvPicPr>
             <a:picLocks noChangeAspect="1"/>
           </p:cNvPicPr>
           <p:nvPr/>
         </p:nvPicPr>
         <p:blipFill>
-          <a:blip r:embed="rId2"/>
+          <a:blip r:embed="rId3"/>
+          <a:srcRect t="35962" b="35962"/>
           <a:stretch>
             <a:fillRect/>
           </a:stretch>
@@ -9644,1002 +9647,6 @@
       </p:sp>
       <p:sp>
         <p:nvSpPr>
-          <p:cNvPr id="7" name="Rectangle 6"/>
-          <p:cNvSpPr/>
-          <p:nvPr/>
-        </p:nvSpPr>
-        <p:spPr>
-          <a:xfrm>
-            <a:off x="548640" y="3291840"/>
-            <a:ext cx="3703320" cy="640080"/>
-          </a:xfrm>
-          <a:prstGeom prst="rect">
-            <a:avLst/>
-          </a:prstGeom>
-          <a:solidFill>
-            <a:srgbClr val="121823"/>
-          </a:solidFill>
-          <a:ln>
-            <a:noFill/>
-          </a:ln>
-          <a:effectLst/>
-        </p:spPr>
-        <p:style>
-          <a:lnRef idx="1">
-            <a:schemeClr val="accent1"/>
-          </a:lnRef>
-          <a:fillRef idx="3">
-            <a:schemeClr val="accent1"/>
-          </a:fillRef>
-          <a:effectRef idx="2">
-            <a:schemeClr val="accent1"/>
-          </a:effectRef>
-          <a:fontRef idx="minor">
-            <a:schemeClr val="lt1"/>
-          </a:fontRef>
-        </p:style>
-        <p:txBody>
-          <a:bodyPr rtlCol="0" anchor="ctr"/>
-          <a:lstStyle/>
-          <a:p>
-            <a:pPr algn="ctr"/>
-          </a:p>
-        </p:txBody>
-      </p:sp>
-      <p:sp>
-        <p:nvSpPr>
-          <p:cNvPr id="8" name="TextBox 7"/>
-          <p:cNvSpPr txBox="1"/>
-          <p:nvPr/>
-        </p:nvSpPr>
-        <p:spPr>
-          <a:xfrm>
-            <a:off x="822960" y="3291840"/>
-            <a:ext cx="3429000" cy="640080"/>
-          </a:xfrm>
-          <a:prstGeom prst="rect">
-            <a:avLst/>
-          </a:prstGeom>
-          <a:noFill/>
-        </p:spPr>
-        <p:txBody>
-          <a:bodyPr wrap="square" lIns="0" rIns="0" tIns="0" bIns="0" anchor="ctr">
-            <a:spAutoFit/>
-          </a:bodyPr>
-          <a:lstStyle/>
-          <a:p>
-            <a:pPr algn="l">
-              <a:lnSpc>
-                <a:spcPct val="100000"/>
-              </a:lnSpc>
-            </a:pPr>
-            <a:r>
-              <a:rPr sz="1400" b="1" spc="-20">
-                <a:solidFill>
-                  <a:srgbClr val="FFFFFF"/>
-                </a:solidFill>
-                <a:latin typeface="Helvetica Neue"/>
-              </a:rPr>
-              <a:t>Commercial Solutions</a:t>
-            </a:r>
-          </a:p>
-        </p:txBody>
-      </p:sp>
-      <p:sp>
-        <p:nvSpPr>
-          <p:cNvPr id="9" name="Rectangle 8"/>
-          <p:cNvSpPr/>
-          <p:nvPr/>
-        </p:nvSpPr>
-        <p:spPr>
-          <a:xfrm>
-            <a:off x="4343400" y="3291840"/>
-            <a:ext cx="3703320" cy="640080"/>
-          </a:xfrm>
-          <a:prstGeom prst="rect">
-            <a:avLst/>
-          </a:prstGeom>
-          <a:solidFill>
-            <a:srgbClr val="121823"/>
-          </a:solidFill>
-          <a:ln>
-            <a:noFill/>
-          </a:ln>
-          <a:effectLst/>
-        </p:spPr>
-        <p:style>
-          <a:lnRef idx="1">
-            <a:schemeClr val="accent1"/>
-          </a:lnRef>
-          <a:fillRef idx="3">
-            <a:schemeClr val="accent1"/>
-          </a:fillRef>
-          <a:effectRef idx="2">
-            <a:schemeClr val="accent1"/>
-          </a:effectRef>
-          <a:fontRef idx="minor">
-            <a:schemeClr val="lt1"/>
-          </a:fontRef>
-        </p:style>
-        <p:txBody>
-          <a:bodyPr rtlCol="0" anchor="ctr"/>
-          <a:lstStyle/>
-          <a:p>
-            <a:pPr algn="ctr"/>
-          </a:p>
-        </p:txBody>
-      </p:sp>
-      <p:sp>
-        <p:nvSpPr>
-          <p:cNvPr id="10" name="TextBox 9"/>
-          <p:cNvSpPr txBox="1"/>
-          <p:nvPr/>
-        </p:nvSpPr>
-        <p:spPr>
-          <a:xfrm>
-            <a:off x="4617720" y="3291840"/>
-            <a:ext cx="3429000" cy="640080"/>
-          </a:xfrm>
-          <a:prstGeom prst="rect">
-            <a:avLst/>
-          </a:prstGeom>
-          <a:noFill/>
-        </p:spPr>
-        <p:txBody>
-          <a:bodyPr wrap="square" lIns="0" rIns="0" tIns="0" bIns="0" anchor="ctr">
-            <a:spAutoFit/>
-          </a:bodyPr>
-          <a:lstStyle/>
-          <a:p>
-            <a:pPr algn="l">
-              <a:lnSpc>
-                <a:spcPct val="100000"/>
-              </a:lnSpc>
-            </a:pPr>
-            <a:r>
-              <a:rPr sz="1400" b="1" spc="-20">
-                <a:solidFill>
-                  <a:srgbClr val="FFFFFF"/>
-                </a:solidFill>
-                <a:latin typeface="Helvetica Neue"/>
-              </a:rPr>
-              <a:t>UnderTerra</a:t>
-            </a:r>
-          </a:p>
-        </p:txBody>
-      </p:sp>
-      <p:sp>
-        <p:nvSpPr>
-          <p:cNvPr id="11" name="Rectangle 10"/>
-          <p:cNvSpPr/>
-          <p:nvPr/>
-        </p:nvSpPr>
-        <p:spPr>
-          <a:xfrm>
-            <a:off x="8138160" y="3291840"/>
-            <a:ext cx="3703320" cy="640080"/>
-          </a:xfrm>
-          <a:prstGeom prst="rect">
-            <a:avLst/>
-          </a:prstGeom>
-          <a:solidFill>
-            <a:srgbClr val="121823"/>
-          </a:solidFill>
-          <a:ln>
-            <a:noFill/>
-          </a:ln>
-          <a:effectLst/>
-        </p:spPr>
-        <p:style>
-          <a:lnRef idx="1">
-            <a:schemeClr val="accent1"/>
-          </a:lnRef>
-          <a:fillRef idx="3">
-            <a:schemeClr val="accent1"/>
-          </a:fillRef>
-          <a:effectRef idx="2">
-            <a:schemeClr val="accent1"/>
-          </a:effectRef>
-          <a:fontRef idx="minor">
-            <a:schemeClr val="lt1"/>
-          </a:fontRef>
-        </p:style>
-        <p:txBody>
-          <a:bodyPr rtlCol="0" anchor="ctr"/>
-          <a:lstStyle/>
-          <a:p>
-            <a:pPr algn="ctr"/>
-          </a:p>
-        </p:txBody>
-      </p:sp>
-      <p:sp>
-        <p:nvSpPr>
-          <p:cNvPr id="12" name="TextBox 11"/>
-          <p:cNvSpPr txBox="1"/>
-          <p:nvPr/>
-        </p:nvSpPr>
-        <p:spPr>
-          <a:xfrm>
-            <a:off x="8412480" y="3291840"/>
-            <a:ext cx="3429000" cy="640080"/>
-          </a:xfrm>
-          <a:prstGeom prst="rect">
-            <a:avLst/>
-          </a:prstGeom>
-          <a:noFill/>
-        </p:spPr>
-        <p:txBody>
-          <a:bodyPr wrap="square" lIns="0" rIns="0" tIns="0" bIns="0" anchor="ctr">
-            <a:spAutoFit/>
-          </a:bodyPr>
-          <a:lstStyle/>
-          <a:p>
-            <a:pPr algn="l">
-              <a:lnSpc>
-                <a:spcPct val="100000"/>
-              </a:lnSpc>
-            </a:pPr>
-            <a:r>
-              <a:rPr sz="1400" b="1" spc="-20">
-                <a:solidFill>
-                  <a:srgbClr val="FFFFFF"/>
-                </a:solidFill>
-                <a:latin typeface="Helvetica Neue"/>
-              </a:rPr>
-              <a:t>Doer-Fer</a:t>
-            </a:r>
-          </a:p>
-        </p:txBody>
-      </p:sp>
-      <p:sp>
-        <p:nvSpPr>
-          <p:cNvPr id="13" name="Rectangle 12"/>
-          <p:cNvSpPr/>
-          <p:nvPr/>
-        </p:nvSpPr>
-        <p:spPr>
-          <a:xfrm>
-            <a:off x="548640" y="4005072"/>
-            <a:ext cx="3703320" cy="640080"/>
-          </a:xfrm>
-          <a:prstGeom prst="rect">
-            <a:avLst/>
-          </a:prstGeom>
-          <a:solidFill>
-            <a:srgbClr val="121823"/>
-          </a:solidFill>
-          <a:ln>
-            <a:noFill/>
-          </a:ln>
-          <a:effectLst/>
-        </p:spPr>
-        <p:style>
-          <a:lnRef idx="1">
-            <a:schemeClr val="accent1"/>
-          </a:lnRef>
-          <a:fillRef idx="3">
-            <a:schemeClr val="accent1"/>
-          </a:fillRef>
-          <a:effectRef idx="2">
-            <a:schemeClr val="accent1"/>
-          </a:effectRef>
-          <a:fontRef idx="minor">
-            <a:schemeClr val="lt1"/>
-          </a:fontRef>
-        </p:style>
-        <p:txBody>
-          <a:bodyPr rtlCol="0" anchor="ctr"/>
-          <a:lstStyle/>
-          <a:p>
-            <a:pPr algn="ctr"/>
-          </a:p>
-        </p:txBody>
-      </p:sp>
-      <p:sp>
-        <p:nvSpPr>
-          <p:cNvPr id="14" name="TextBox 13"/>
-          <p:cNvSpPr txBox="1"/>
-          <p:nvPr/>
-        </p:nvSpPr>
-        <p:spPr>
-          <a:xfrm>
-            <a:off x="822960" y="4005072"/>
-            <a:ext cx="3429000" cy="640080"/>
-          </a:xfrm>
-          <a:prstGeom prst="rect">
-            <a:avLst/>
-          </a:prstGeom>
-          <a:noFill/>
-        </p:spPr>
-        <p:txBody>
-          <a:bodyPr wrap="square" lIns="0" rIns="0" tIns="0" bIns="0" anchor="ctr">
-            <a:spAutoFit/>
-          </a:bodyPr>
-          <a:lstStyle/>
-          <a:p>
-            <a:pPr algn="l">
-              <a:lnSpc>
-                <a:spcPct val="100000"/>
-              </a:lnSpc>
-            </a:pPr>
-            <a:r>
-              <a:rPr sz="1400" b="1" spc="-20">
-                <a:solidFill>
-                  <a:srgbClr val="FFFFFF"/>
-                </a:solidFill>
-                <a:latin typeface="Helvetica Neue"/>
-              </a:rPr>
-              <a:t>General Aluminum</a:t>
-            </a:r>
-          </a:p>
-        </p:txBody>
-      </p:sp>
-      <p:sp>
-        <p:nvSpPr>
-          <p:cNvPr id="15" name="Rectangle 14"/>
-          <p:cNvSpPr/>
-          <p:nvPr/>
-        </p:nvSpPr>
-        <p:spPr>
-          <a:xfrm>
-            <a:off x="4343400" y="4005072"/>
-            <a:ext cx="3703320" cy="640080"/>
-          </a:xfrm>
-          <a:prstGeom prst="rect">
-            <a:avLst/>
-          </a:prstGeom>
-          <a:solidFill>
-            <a:srgbClr val="121823"/>
-          </a:solidFill>
-          <a:ln>
-            <a:noFill/>
-          </a:ln>
-          <a:effectLst/>
-        </p:spPr>
-        <p:style>
-          <a:lnRef idx="1">
-            <a:schemeClr val="accent1"/>
-          </a:lnRef>
-          <a:fillRef idx="3">
-            <a:schemeClr val="accent1"/>
-          </a:fillRef>
-          <a:effectRef idx="2">
-            <a:schemeClr val="accent1"/>
-          </a:effectRef>
-          <a:fontRef idx="minor">
-            <a:schemeClr val="lt1"/>
-          </a:fontRef>
-        </p:style>
-        <p:txBody>
-          <a:bodyPr rtlCol="0" anchor="ctr"/>
-          <a:lstStyle/>
-          <a:p>
-            <a:pPr algn="ctr"/>
-          </a:p>
-        </p:txBody>
-      </p:sp>
-      <p:sp>
-        <p:nvSpPr>
-          <p:cNvPr id="16" name="TextBox 15"/>
-          <p:cNvSpPr txBox="1"/>
-          <p:nvPr/>
-        </p:nvSpPr>
-        <p:spPr>
-          <a:xfrm>
-            <a:off x="4617720" y="4005072"/>
-            <a:ext cx="3429000" cy="640080"/>
-          </a:xfrm>
-          <a:prstGeom prst="rect">
-            <a:avLst/>
-          </a:prstGeom>
-          <a:noFill/>
-        </p:spPr>
-        <p:txBody>
-          <a:bodyPr wrap="square" lIns="0" rIns="0" tIns="0" bIns="0" anchor="ctr">
-            <a:spAutoFit/>
-          </a:bodyPr>
-          <a:lstStyle/>
-          <a:p>
-            <a:pPr algn="l">
-              <a:lnSpc>
-                <a:spcPct val="100000"/>
-              </a:lnSpc>
-            </a:pPr>
-            <a:r>
-              <a:rPr sz="1400" b="1" spc="-20">
-                <a:solidFill>
-                  <a:srgbClr val="FFFFFF"/>
-                </a:solidFill>
-                <a:latin typeface="Helvetica Neue"/>
-              </a:rPr>
-              <a:t>Gentherm</a:t>
-            </a:r>
-          </a:p>
-        </p:txBody>
-      </p:sp>
-      <p:sp>
-        <p:nvSpPr>
-          <p:cNvPr id="17" name="Rectangle 16"/>
-          <p:cNvSpPr/>
-          <p:nvPr/>
-        </p:nvSpPr>
-        <p:spPr>
-          <a:xfrm>
-            <a:off x="8138160" y="4005072"/>
-            <a:ext cx="3703320" cy="640080"/>
-          </a:xfrm>
-          <a:prstGeom prst="rect">
-            <a:avLst/>
-          </a:prstGeom>
-          <a:solidFill>
-            <a:srgbClr val="121823"/>
-          </a:solidFill>
-          <a:ln>
-            <a:noFill/>
-          </a:ln>
-          <a:effectLst/>
-        </p:spPr>
-        <p:style>
-          <a:lnRef idx="1">
-            <a:schemeClr val="accent1"/>
-          </a:lnRef>
-          <a:fillRef idx="3">
-            <a:schemeClr val="accent1"/>
-          </a:fillRef>
-          <a:effectRef idx="2">
-            <a:schemeClr val="accent1"/>
-          </a:effectRef>
-          <a:fontRef idx="minor">
-            <a:schemeClr val="lt1"/>
-          </a:fontRef>
-        </p:style>
-        <p:txBody>
-          <a:bodyPr rtlCol="0" anchor="ctr"/>
-          <a:lstStyle/>
-          <a:p>
-            <a:pPr algn="ctr"/>
-          </a:p>
-        </p:txBody>
-      </p:sp>
-      <p:sp>
-        <p:nvSpPr>
-          <p:cNvPr id="18" name="TextBox 17"/>
-          <p:cNvSpPr txBox="1"/>
-          <p:nvPr/>
-        </p:nvSpPr>
-        <p:spPr>
-          <a:xfrm>
-            <a:off x="8412480" y="4005072"/>
-            <a:ext cx="3429000" cy="640080"/>
-          </a:xfrm>
-          <a:prstGeom prst="rect">
-            <a:avLst/>
-          </a:prstGeom>
-          <a:noFill/>
-        </p:spPr>
-        <p:txBody>
-          <a:bodyPr wrap="square" lIns="0" rIns="0" tIns="0" bIns="0" anchor="ctr">
-            <a:spAutoFit/>
-          </a:bodyPr>
-          <a:lstStyle/>
-          <a:p>
-            <a:pPr algn="l">
-              <a:lnSpc>
-                <a:spcPct val="100000"/>
-              </a:lnSpc>
-            </a:pPr>
-            <a:r>
-              <a:rPr sz="1400" b="1" spc="-20">
-                <a:solidFill>
-                  <a:srgbClr val="FFFFFF"/>
-                </a:solidFill>
-                <a:latin typeface="Helvetica Neue"/>
-              </a:rPr>
-              <a:t>General Electric</a:t>
-            </a:r>
-          </a:p>
-        </p:txBody>
-      </p:sp>
-      <p:sp>
-        <p:nvSpPr>
-          <p:cNvPr id="19" name="Rectangle 18"/>
-          <p:cNvSpPr/>
-          <p:nvPr/>
-        </p:nvSpPr>
-        <p:spPr>
-          <a:xfrm>
-            <a:off x="548640" y="4718304"/>
-            <a:ext cx="3703320" cy="640080"/>
-          </a:xfrm>
-          <a:prstGeom prst="rect">
-            <a:avLst/>
-          </a:prstGeom>
-          <a:solidFill>
-            <a:srgbClr val="121823"/>
-          </a:solidFill>
-          <a:ln>
-            <a:noFill/>
-          </a:ln>
-          <a:effectLst/>
-        </p:spPr>
-        <p:style>
-          <a:lnRef idx="1">
-            <a:schemeClr val="accent1"/>
-          </a:lnRef>
-          <a:fillRef idx="3">
-            <a:schemeClr val="accent1"/>
-          </a:fillRef>
-          <a:effectRef idx="2">
-            <a:schemeClr val="accent1"/>
-          </a:effectRef>
-          <a:fontRef idx="minor">
-            <a:schemeClr val="lt1"/>
-          </a:fontRef>
-        </p:style>
-        <p:txBody>
-          <a:bodyPr rtlCol="0" anchor="ctr"/>
-          <a:lstStyle/>
-          <a:p>
-            <a:pPr algn="ctr"/>
-          </a:p>
-        </p:txBody>
-      </p:sp>
-      <p:sp>
-        <p:nvSpPr>
-          <p:cNvPr id="20" name="TextBox 19"/>
-          <p:cNvSpPr txBox="1"/>
-          <p:nvPr/>
-        </p:nvSpPr>
-        <p:spPr>
-          <a:xfrm>
-            <a:off x="822960" y="4718304"/>
-            <a:ext cx="3429000" cy="640080"/>
-          </a:xfrm>
-          <a:prstGeom prst="rect">
-            <a:avLst/>
-          </a:prstGeom>
-          <a:noFill/>
-        </p:spPr>
-        <p:txBody>
-          <a:bodyPr wrap="square" lIns="0" rIns="0" tIns="0" bIns="0" anchor="ctr">
-            <a:spAutoFit/>
-          </a:bodyPr>
-          <a:lstStyle/>
-          <a:p>
-            <a:pPr algn="l">
-              <a:lnSpc>
-                <a:spcPct val="100000"/>
-              </a:lnSpc>
-            </a:pPr>
-            <a:r>
-              <a:rPr sz="1400" b="1" spc="-20">
-                <a:solidFill>
-                  <a:srgbClr val="FFFFFF"/>
-                </a:solidFill>
-                <a:latin typeface="Helvetica Neue"/>
-              </a:rPr>
-              <a:t>NAFTA Traders</a:t>
-            </a:r>
-          </a:p>
-        </p:txBody>
-      </p:sp>
-      <p:sp>
-        <p:nvSpPr>
-          <p:cNvPr id="21" name="Rectangle 20"/>
-          <p:cNvSpPr/>
-          <p:nvPr/>
-        </p:nvSpPr>
-        <p:spPr>
-          <a:xfrm>
-            <a:off x="4343400" y="4718304"/>
-            <a:ext cx="3703320" cy="640080"/>
-          </a:xfrm>
-          <a:prstGeom prst="rect">
-            <a:avLst/>
-          </a:prstGeom>
-          <a:solidFill>
-            <a:srgbClr val="121823"/>
-          </a:solidFill>
-          <a:ln>
-            <a:noFill/>
-          </a:ln>
-          <a:effectLst/>
-        </p:spPr>
-        <p:style>
-          <a:lnRef idx="1">
-            <a:schemeClr val="accent1"/>
-          </a:lnRef>
-          <a:fillRef idx="3">
-            <a:schemeClr val="accent1"/>
-          </a:fillRef>
-          <a:effectRef idx="2">
-            <a:schemeClr val="accent1"/>
-          </a:effectRef>
-          <a:fontRef idx="minor">
-            <a:schemeClr val="lt1"/>
-          </a:fontRef>
-        </p:style>
-        <p:txBody>
-          <a:bodyPr rtlCol="0" anchor="ctr"/>
-          <a:lstStyle/>
-          <a:p>
-            <a:pPr algn="ctr"/>
-          </a:p>
-        </p:txBody>
-      </p:sp>
-      <p:sp>
-        <p:nvSpPr>
-          <p:cNvPr id="22" name="TextBox 21"/>
-          <p:cNvSpPr txBox="1"/>
-          <p:nvPr/>
-        </p:nvSpPr>
-        <p:spPr>
-          <a:xfrm>
-            <a:off x="4617720" y="4718304"/>
-            <a:ext cx="3429000" cy="640080"/>
-          </a:xfrm>
-          <a:prstGeom prst="rect">
-            <a:avLst/>
-          </a:prstGeom>
-          <a:noFill/>
-        </p:spPr>
-        <p:txBody>
-          <a:bodyPr wrap="square" lIns="0" rIns="0" tIns="0" bIns="0" anchor="ctr">
-            <a:spAutoFit/>
-          </a:bodyPr>
-          <a:lstStyle/>
-          <a:p>
-            <a:pPr algn="l">
-              <a:lnSpc>
-                <a:spcPct val="100000"/>
-              </a:lnSpc>
-            </a:pPr>
-            <a:r>
-              <a:rPr sz="1400" b="1" spc="-20">
-                <a:solidFill>
-                  <a:srgbClr val="FFFFFF"/>
-                </a:solidFill>
-                <a:latin typeface="Helvetica Neue"/>
-              </a:rPr>
-              <a:t>Beck Steel</a:t>
-            </a:r>
-          </a:p>
-        </p:txBody>
-      </p:sp>
-      <p:sp>
-        <p:nvSpPr>
-          <p:cNvPr id="23" name="Rectangle 22"/>
-          <p:cNvSpPr/>
-          <p:nvPr/>
-        </p:nvSpPr>
-        <p:spPr>
-          <a:xfrm>
-            <a:off x="8138160" y="4718304"/>
-            <a:ext cx="3703320" cy="640080"/>
-          </a:xfrm>
-          <a:prstGeom prst="rect">
-            <a:avLst/>
-          </a:prstGeom>
-          <a:solidFill>
-            <a:srgbClr val="121823"/>
-          </a:solidFill>
-          <a:ln>
-            <a:noFill/>
-          </a:ln>
-          <a:effectLst/>
-        </p:spPr>
-        <p:style>
-          <a:lnRef idx="1">
-            <a:schemeClr val="accent1"/>
-          </a:lnRef>
-          <a:fillRef idx="3">
-            <a:schemeClr val="accent1"/>
-          </a:fillRef>
-          <a:effectRef idx="2">
-            <a:schemeClr val="accent1"/>
-          </a:effectRef>
-          <a:fontRef idx="minor">
-            <a:schemeClr val="lt1"/>
-          </a:fontRef>
-        </p:style>
-        <p:txBody>
-          <a:bodyPr rtlCol="0" anchor="ctr"/>
-          <a:lstStyle/>
-          <a:p>
-            <a:pPr algn="ctr"/>
-          </a:p>
-        </p:txBody>
-      </p:sp>
-      <p:sp>
-        <p:nvSpPr>
-          <p:cNvPr id="24" name="TextBox 23"/>
-          <p:cNvSpPr txBox="1"/>
-          <p:nvPr/>
-        </p:nvSpPr>
-        <p:spPr>
-          <a:xfrm>
-            <a:off x="8412480" y="4718304"/>
-            <a:ext cx="3429000" cy="640080"/>
-          </a:xfrm>
-          <a:prstGeom prst="rect">
-            <a:avLst/>
-          </a:prstGeom>
-          <a:noFill/>
-        </p:spPr>
-        <p:txBody>
-          <a:bodyPr wrap="square" lIns="0" rIns="0" tIns="0" bIns="0" anchor="ctr">
-            <a:spAutoFit/>
-          </a:bodyPr>
-          <a:lstStyle/>
-          <a:p>
-            <a:pPr algn="l">
-              <a:lnSpc>
-                <a:spcPct val="100000"/>
-              </a:lnSpc>
-            </a:pPr>
-            <a:r>
-              <a:rPr sz="1400" b="1" spc="-20">
-                <a:solidFill>
-                  <a:srgbClr val="FFFFFF"/>
-                </a:solidFill>
-                <a:latin typeface="Helvetica Neue"/>
-              </a:rPr>
-              <a:t>ParkOhio</a:t>
-            </a:r>
-          </a:p>
-        </p:txBody>
-      </p:sp>
-      <p:sp>
-        <p:nvSpPr>
-          <p:cNvPr id="25" name="Rectangle 24"/>
-          <p:cNvSpPr/>
-          <p:nvPr/>
-        </p:nvSpPr>
-        <p:spPr>
-          <a:xfrm>
-            <a:off x="548640" y="5431536"/>
-            <a:ext cx="3703320" cy="640080"/>
-          </a:xfrm>
-          <a:prstGeom prst="rect">
-            <a:avLst/>
-          </a:prstGeom>
-          <a:solidFill>
-            <a:srgbClr val="121823"/>
-          </a:solidFill>
-          <a:ln>
-            <a:noFill/>
-          </a:ln>
-          <a:effectLst/>
-        </p:spPr>
-        <p:style>
-          <a:lnRef idx="1">
-            <a:schemeClr val="accent1"/>
-          </a:lnRef>
-          <a:fillRef idx="3">
-            <a:schemeClr val="accent1"/>
-          </a:fillRef>
-          <a:effectRef idx="2">
-            <a:schemeClr val="accent1"/>
-          </a:effectRef>
-          <a:fontRef idx="minor">
-            <a:schemeClr val="lt1"/>
-          </a:fontRef>
-        </p:style>
-        <p:txBody>
-          <a:bodyPr rtlCol="0" anchor="ctr"/>
-          <a:lstStyle/>
-          <a:p>
-            <a:pPr algn="ctr"/>
-          </a:p>
-        </p:txBody>
-      </p:sp>
-      <p:sp>
-        <p:nvSpPr>
-          <p:cNvPr id="26" name="TextBox 25"/>
-          <p:cNvSpPr txBox="1"/>
-          <p:nvPr/>
-        </p:nvSpPr>
-        <p:spPr>
-          <a:xfrm>
-            <a:off x="822960" y="5431536"/>
-            <a:ext cx="3429000" cy="640080"/>
-          </a:xfrm>
-          <a:prstGeom prst="rect">
-            <a:avLst/>
-          </a:prstGeom>
-          <a:noFill/>
-        </p:spPr>
-        <p:txBody>
-          <a:bodyPr wrap="square" lIns="0" rIns="0" tIns="0" bIns="0" anchor="ctr">
-            <a:spAutoFit/>
-          </a:bodyPr>
-          <a:lstStyle/>
-          <a:p>
-            <a:pPr algn="l">
-              <a:lnSpc>
-                <a:spcPct val="100000"/>
-              </a:lnSpc>
-            </a:pPr>
-            <a:r>
-              <a:rPr sz="1400" b="1" spc="-20">
-                <a:solidFill>
-                  <a:srgbClr val="FFFFFF"/>
-                </a:solidFill>
-                <a:latin typeface="Helvetica Neue"/>
-              </a:rPr>
-              <a:t>Resco</a:t>
-            </a:r>
-          </a:p>
-        </p:txBody>
-      </p:sp>
-      <p:sp>
-        <p:nvSpPr>
-          <p:cNvPr id="27" name="Rectangle 26"/>
-          <p:cNvSpPr/>
-          <p:nvPr/>
-        </p:nvSpPr>
-        <p:spPr>
-          <a:xfrm>
-            <a:off x="4343400" y="5431536"/>
-            <a:ext cx="3703320" cy="640080"/>
-          </a:xfrm>
-          <a:prstGeom prst="rect">
-            <a:avLst/>
-          </a:prstGeom>
-          <a:solidFill>
-            <a:srgbClr val="121823"/>
-          </a:solidFill>
-          <a:ln>
-            <a:noFill/>
-          </a:ln>
-          <a:effectLst/>
-        </p:spPr>
-        <p:style>
-          <a:lnRef idx="1">
-            <a:schemeClr val="accent1"/>
-          </a:lnRef>
-          <a:fillRef idx="3">
-            <a:schemeClr val="accent1"/>
-          </a:fillRef>
-          <a:effectRef idx="2">
-            <a:schemeClr val="accent1"/>
-          </a:effectRef>
-          <a:fontRef idx="minor">
-            <a:schemeClr val="lt1"/>
-          </a:fontRef>
-        </p:style>
-        <p:txBody>
-          <a:bodyPr rtlCol="0" anchor="ctr"/>
-          <a:lstStyle/>
-          <a:p>
-            <a:pPr algn="ctr"/>
-          </a:p>
-        </p:txBody>
-      </p:sp>
-      <p:sp>
-        <p:nvSpPr>
-          <p:cNvPr id="28" name="TextBox 27"/>
-          <p:cNvSpPr txBox="1"/>
-          <p:nvPr/>
-        </p:nvSpPr>
-        <p:spPr>
-          <a:xfrm>
-            <a:off x="4617720" y="5431536"/>
-            <a:ext cx="3429000" cy="640080"/>
-          </a:xfrm>
-          <a:prstGeom prst="rect">
-            <a:avLst/>
-          </a:prstGeom>
-          <a:noFill/>
-        </p:spPr>
-        <p:txBody>
-          <a:bodyPr wrap="square" lIns="0" rIns="0" tIns="0" bIns="0" anchor="ctr">
-            <a:spAutoFit/>
-          </a:bodyPr>
-          <a:lstStyle/>
-          <a:p>
-            <a:pPr algn="l">
-              <a:lnSpc>
-                <a:spcPct val="100000"/>
-              </a:lnSpc>
-            </a:pPr>
-            <a:r>
-              <a:rPr sz="1400" b="1" spc="-20">
-                <a:solidFill>
-                  <a:srgbClr val="FFFFFF"/>
-                </a:solidFill>
-                <a:latin typeface="Helvetica Neue"/>
-              </a:rPr>
-              <a:t>Sanford Enterprises</a:t>
-            </a:r>
-          </a:p>
-        </p:txBody>
-      </p:sp>
-      <p:sp>
-        <p:nvSpPr>
-          <p:cNvPr id="29" name="Rectangle 28"/>
-          <p:cNvSpPr/>
-          <p:nvPr/>
-        </p:nvSpPr>
-        <p:spPr>
-          <a:xfrm>
-            <a:off x="8138160" y="5431536"/>
-            <a:ext cx="3703320" cy="640080"/>
-          </a:xfrm>
-          <a:prstGeom prst="rect">
-            <a:avLst/>
-          </a:prstGeom>
-          <a:solidFill>
-            <a:srgbClr val="121823"/>
-          </a:solidFill>
-          <a:ln>
-            <a:noFill/>
-          </a:ln>
-          <a:effectLst/>
-        </p:spPr>
-        <p:style>
-          <a:lnRef idx="1">
-            <a:schemeClr val="accent1"/>
-          </a:lnRef>
-          <a:fillRef idx="3">
-            <a:schemeClr val="accent1"/>
-          </a:fillRef>
-          <a:effectRef idx="2">
-            <a:schemeClr val="accent1"/>
-          </a:effectRef>
-          <a:fontRef idx="minor">
-            <a:schemeClr val="lt1"/>
-          </a:fontRef>
-        </p:style>
-        <p:txBody>
-          <a:bodyPr rtlCol="0" anchor="ctr"/>
-          <a:lstStyle/>
-          <a:p>
-            <a:pPr algn="ctr"/>
-          </a:p>
-        </p:txBody>
-      </p:sp>
-      <p:sp>
-        <p:nvSpPr>
-          <p:cNvPr id="30" name="TextBox 29"/>
-          <p:cNvSpPr txBox="1"/>
-          <p:nvPr/>
-        </p:nvSpPr>
-        <p:spPr>
-          <a:xfrm>
-            <a:off x="8412480" y="5431536"/>
-            <a:ext cx="3429000" cy="640080"/>
-          </a:xfrm>
-          <a:prstGeom prst="rect">
-            <a:avLst/>
-          </a:prstGeom>
-          <a:noFill/>
-        </p:spPr>
-        <p:txBody>
-          <a:bodyPr wrap="square" lIns="0" rIns="0" tIns="0" bIns="0" anchor="ctr">
-            <a:spAutoFit/>
-          </a:bodyPr>
-          <a:lstStyle/>
-          <a:p>
-            <a:pPr algn="l">
-              <a:lnSpc>
-                <a:spcPct val="100000"/>
-              </a:lnSpc>
-            </a:pPr>
-            <a:r>
-              <a:rPr sz="1400" b="1" spc="-20">
-                <a:solidFill>
-                  <a:srgbClr val="FFFFFF"/>
-                </a:solidFill>
-                <a:latin typeface="Helvetica Neue"/>
-              </a:rPr>
-              <a:t>CSI</a:t>
-            </a:r>
-          </a:p>
-        </p:txBody>
-      </p:sp>
-      <p:sp>
-        <p:nvSpPr>
           <p:cNvPr id="31" name="TextBox 30"/>
           <p:cNvSpPr txBox="1"/>
           <p:nvPr/>
@@ -10716,6 +9723,318 @@
           </a:p>
         </p:txBody>
       </p:sp>
+      <p:pic>
+        <p:nvPicPr>
+          <p:cNvPr id="33" name="Picture 32" descr="current.png"/>
+          <p:cNvPicPr>
+            <a:picLocks noChangeAspect="1"/>
+          </p:cNvPicPr>
+          <p:nvPr/>
+        </p:nvPicPr>
+        <p:blipFill>
+          <a:blip r:embed="rId2"/>
+          <a:stretch>
+            <a:fillRect/>
+          </a:stretch>
+        </p:blipFill>
+        <p:spPr>
+          <a:xfrm>
+            <a:off x="713231" y="3512440"/>
+            <a:ext cx="1889150" cy="320799"/>
+          </a:xfrm>
+          <a:prstGeom prst="rect">
+            <a:avLst/>
+          </a:prstGeom>
+        </p:spPr>
+      </p:pic>
+      <p:pic>
+        <p:nvPicPr>
+          <p:cNvPr id="34" name="Picture 33" descr="terrapods.png"/>
+          <p:cNvPicPr>
+            <a:picLocks noChangeAspect="1"/>
+          </p:cNvPicPr>
+          <p:nvPr/>
+        </p:nvPicPr>
+        <p:blipFill>
+          <a:blip r:embed="rId3"/>
+          <a:stretch>
+            <a:fillRect/>
+          </a:stretch>
+        </p:blipFill>
+        <p:spPr>
+          <a:xfrm>
+            <a:off x="3103834" y="3273552"/>
+            <a:ext cx="1544614" cy="798575"/>
+          </a:xfrm>
+          <a:prstGeom prst="rect">
+            <a:avLst/>
+          </a:prstGeom>
+        </p:spPr>
+      </p:pic>
+      <p:pic>
+        <p:nvPicPr>
+          <p:cNvPr id="35" name="Picture 34" descr="resco.png"/>
+          <p:cNvPicPr>
+            <a:picLocks noChangeAspect="1"/>
+          </p:cNvPicPr>
+          <p:nvPr/>
+        </p:nvPicPr>
+        <p:blipFill>
+          <a:blip r:embed="rId4"/>
+          <a:stretch>
+            <a:fillRect/>
+          </a:stretch>
+        </p:blipFill>
+        <p:spPr>
+          <a:xfrm>
+            <a:off x="5149900" y="3382579"/>
+            <a:ext cx="1889150" cy="580520"/>
+          </a:xfrm>
+          <a:prstGeom prst="rect">
+            <a:avLst/>
+          </a:prstGeom>
+        </p:spPr>
+      </p:pic>
+      <p:pic>
+        <p:nvPicPr>
+          <p:cNvPr id="36" name="Picture 35" descr="commercial-solutions.png"/>
+          <p:cNvPicPr>
+            <a:picLocks noChangeAspect="1"/>
+          </p:cNvPicPr>
+          <p:nvPr/>
+        </p:nvPicPr>
+        <p:blipFill>
+          <a:blip r:embed="rId5"/>
+          <a:stretch>
+            <a:fillRect/>
+          </a:stretch>
+        </p:blipFill>
+        <p:spPr>
+          <a:xfrm>
+            <a:off x="7368235" y="3420623"/>
+            <a:ext cx="1889150" cy="504432"/>
+          </a:xfrm>
+          <a:prstGeom prst="rect">
+            <a:avLst/>
+          </a:prstGeom>
+        </p:spPr>
+      </p:pic>
+      <p:pic>
+        <p:nvPicPr>
+          <p:cNvPr id="37" name="Picture 36" descr="nafta.png"/>
+          <p:cNvPicPr>
+            <a:picLocks noChangeAspect="1"/>
+          </p:cNvPicPr>
+          <p:nvPr/>
+        </p:nvPicPr>
+        <p:blipFill>
+          <a:blip r:embed="rId6"/>
+          <a:stretch>
+            <a:fillRect/>
+          </a:stretch>
+        </p:blipFill>
+        <p:spPr>
+          <a:xfrm>
+            <a:off x="10143265" y="3273552"/>
+            <a:ext cx="775759" cy="798575"/>
+          </a:xfrm>
+          <a:prstGeom prst="rect">
+            <a:avLst/>
+          </a:prstGeom>
+        </p:spPr>
+      </p:pic>
+      <p:pic>
+        <p:nvPicPr>
+          <p:cNvPr id="38" name="Picture 37" descr="underterra.png"/>
+          <p:cNvPicPr>
+            <a:picLocks noChangeAspect="1"/>
+          </p:cNvPicPr>
+          <p:nvPr/>
+        </p:nvPicPr>
+        <p:blipFill>
+          <a:blip r:embed="rId7"/>
+          <a:stretch>
+            <a:fillRect/>
+          </a:stretch>
+        </p:blipFill>
+        <p:spPr>
+          <a:xfrm>
+            <a:off x="713231" y="4559083"/>
+            <a:ext cx="1889150" cy="300152"/>
+          </a:xfrm>
+          <a:prstGeom prst="rect">
+            <a:avLst/>
+          </a:prstGeom>
+        </p:spPr>
+      </p:pic>
+      <p:pic>
+        <p:nvPicPr>
+          <p:cNvPr id="39" name="Picture 38" descr="becksteel.png"/>
+          <p:cNvPicPr>
+            <a:picLocks noChangeAspect="1"/>
+          </p:cNvPicPr>
+          <p:nvPr/>
+        </p:nvPicPr>
+        <p:blipFill>
+          <a:blip r:embed="rId8"/>
+          <a:stretch>
+            <a:fillRect/>
+          </a:stretch>
+        </p:blipFill>
+        <p:spPr>
+          <a:xfrm>
+            <a:off x="2931566" y="4460843"/>
+            <a:ext cx="1889150" cy="496632"/>
+          </a:xfrm>
+          <a:prstGeom prst="rect">
+            <a:avLst/>
+          </a:prstGeom>
+        </p:spPr>
+      </p:pic>
+      <p:pic>
+        <p:nvPicPr>
+          <p:cNvPr id="40" name="Picture 39" descr="sanford.png"/>
+          <p:cNvPicPr>
+            <a:picLocks noChangeAspect="1"/>
+          </p:cNvPicPr>
+          <p:nvPr/>
+        </p:nvPicPr>
+        <p:blipFill>
+          <a:blip r:embed="rId9"/>
+          <a:stretch>
+            <a:fillRect/>
+          </a:stretch>
+        </p:blipFill>
+        <p:spPr>
+          <a:xfrm>
+            <a:off x="5149900" y="4491958"/>
+            <a:ext cx="1889150" cy="434403"/>
+          </a:xfrm>
+          <a:prstGeom prst="rect">
+            <a:avLst/>
+          </a:prstGeom>
+        </p:spPr>
+      </p:pic>
+      <p:pic>
+        <p:nvPicPr>
+          <p:cNvPr id="41" name="Picture 40" descr="doerfer.png"/>
+          <p:cNvPicPr>
+            <a:picLocks noChangeAspect="1"/>
+          </p:cNvPicPr>
+          <p:nvPr/>
+        </p:nvPicPr>
+        <p:blipFill>
+          <a:blip r:embed="rId10"/>
+          <a:stretch>
+            <a:fillRect/>
+          </a:stretch>
+        </p:blipFill>
+        <p:spPr>
+          <a:xfrm>
+            <a:off x="7368235" y="4446073"/>
+            <a:ext cx="1889150" cy="526172"/>
+          </a:xfrm>
+          <a:prstGeom prst="rect">
+            <a:avLst/>
+          </a:prstGeom>
+        </p:spPr>
+      </p:pic>
+      <p:pic>
+        <p:nvPicPr>
+          <p:cNvPr id="42" name="Picture 41" descr="ge.png"/>
+          <p:cNvPicPr>
+            <a:picLocks noChangeAspect="1"/>
+          </p:cNvPicPr>
+          <p:nvPr/>
+        </p:nvPicPr>
+        <p:blipFill>
+          <a:blip r:embed="rId11"/>
+          <a:stretch>
+            <a:fillRect/>
+          </a:stretch>
+        </p:blipFill>
+        <p:spPr>
+          <a:xfrm>
+            <a:off x="9692362" y="4309872"/>
+            <a:ext cx="1677564" cy="798575"/>
+          </a:xfrm>
+          <a:prstGeom prst="rect">
+            <a:avLst/>
+          </a:prstGeom>
+        </p:spPr>
+      </p:pic>
+      <p:pic>
+        <p:nvPicPr>
+          <p:cNvPr id="43" name="Picture 42" descr="parkohio.png"/>
+          <p:cNvPicPr>
+            <a:picLocks noChangeAspect="1"/>
+          </p:cNvPicPr>
+          <p:nvPr/>
+        </p:nvPicPr>
+        <p:blipFill>
+          <a:blip r:embed="rId12"/>
+          <a:stretch>
+            <a:fillRect/>
+          </a:stretch>
+        </p:blipFill>
+        <p:spPr>
+          <a:xfrm>
+            <a:off x="2931566" y="5479118"/>
+            <a:ext cx="1889150" cy="532722"/>
+          </a:xfrm>
+          <a:prstGeom prst="rect">
+            <a:avLst/>
+          </a:prstGeom>
+        </p:spPr>
+      </p:pic>
+      <p:pic>
+        <p:nvPicPr>
+          <p:cNvPr id="44" name="Picture 43" descr="csi.png"/>
+          <p:cNvPicPr>
+            <a:picLocks noChangeAspect="1"/>
+          </p:cNvPicPr>
+          <p:nvPr/>
+        </p:nvPicPr>
+        <p:blipFill>
+          <a:blip r:embed="rId13"/>
+          <a:stretch>
+            <a:fillRect/>
+          </a:stretch>
+        </p:blipFill>
+        <p:spPr>
+          <a:xfrm>
+            <a:off x="5393024" y="5346192"/>
+            <a:ext cx="1402903" cy="798575"/>
+          </a:xfrm>
+          <a:prstGeom prst="rect">
+            <a:avLst/>
+          </a:prstGeom>
+        </p:spPr>
+      </p:pic>
+      <p:pic>
+        <p:nvPicPr>
+          <p:cNvPr id="45" name="Picture 44" descr="general-aluminum.png"/>
+          <p:cNvPicPr>
+            <a:picLocks noChangeAspect="1"/>
+          </p:cNvPicPr>
+          <p:nvPr/>
+        </p:nvPicPr>
+        <p:blipFill>
+          <a:blip r:embed="rId14"/>
+          <a:stretch>
+            <a:fillRect/>
+          </a:stretch>
+        </p:blipFill>
+        <p:spPr>
+          <a:xfrm>
+            <a:off x="7368235" y="5418045"/>
+            <a:ext cx="1889150" cy="654869"/>
+          </a:xfrm>
+          <a:prstGeom prst="rect">
+            <a:avLst/>
+          </a:prstGeom>
+        </p:spPr>
+      </p:pic>
     </p:spTree>
   </p:cSld>
   <p:clrMapOvr>
@@ -14612,14 +13931,15 @@
       </p:sp>
       <p:pic>
         <p:nvPicPr>
-          <p:cNvPr id="3" name="Picture 2" descr="customs-inspection.jpg"/>
+          <p:cNvPr id="13" name="Picture 12" descr="08-customs-officer.jpg"/>
           <p:cNvPicPr>
             <a:picLocks noChangeAspect="1"/>
           </p:cNvPicPr>
           <p:nvPr/>
         </p:nvPicPr>
         <p:blipFill>
-          <a:blip r:embed="rId2"/>
+          <a:blip r:embed="rId3"/>
+          <a:srcRect t="35962" b="35962"/>
           <a:stretch>
             <a:fillRect/>
           </a:stretch>
@@ -16990,14 +16310,15 @@
       </p:sp>
       <p:pic>
         <p:nvPicPr>
-          <p:cNvPr id="3" name="Picture 2" descr="logistics-strategy.jpg"/>
+          <p:cNvPr id="13" name="Picture 12" descr="10-aerial-logistics.jpg"/>
           <p:cNvPicPr>
             <a:picLocks noChangeAspect="1"/>
           </p:cNvPicPr>
           <p:nvPr/>
         </p:nvPicPr>
         <p:blipFill>
-          <a:blip r:embed="rId2"/>
+          <a:blip r:embed="rId3"/>
+          <a:srcRect t="35962" b="35962"/>
           <a:stretch>
             <a:fillRect/>
           </a:stretch>

</xml_diff>

<commit_message>
Deck v3.1: cinematic landscape photos on slides 7/9/10/11/12
Replace contact-sheet tiles with full landscape shots: aerial port (7),
world map (9), rail crossing (10), container ship (11), highway truck (12).
Slide-17 logo grid rebuild is now idempotent.

Co-Authored-By: Claude Opus 4.7 (1M context) <noreply@anthropic.com>
</commit_message>
<xml_diff>
--- a/public/presentations/ISN-Customs-Brokerage-Deck.pptx
+++ b/public/presentations/ISN-Customs-Brokerage-Deck.pptx
@@ -3741,15 +3741,15 @@
       </p:sp>
       <p:pic>
         <p:nvPicPr>
-          <p:cNvPr id="20" name="Picture 19" descr="04-air-cargo.jpg"/>
+          <p:cNvPr id="20" name="Picture 19" descr="01-rail-crossing.jpg"/>
           <p:cNvPicPr>
             <a:picLocks noChangeAspect="1"/>
           </p:cNvPicPr>
           <p:nvPr/>
         </p:nvPicPr>
         <p:blipFill>
-          <a:blip r:embed="rId3"/>
-          <a:srcRect t="35962" b="35962"/>
+          <a:blip r:embed="rId4"/>
+          <a:srcRect t="7811" b="7811"/>
           <a:stretch>
             <a:fillRect/>
           </a:stretch>
@@ -4518,8 +4518,8 @@
           <p:nvPr/>
         </p:nvPicPr>
         <p:blipFill>
-          <a:blip r:embed="rId3"/>
-          <a:srcRect t="35962" b="35962"/>
+          <a:blip r:embed="rId4"/>
+          <a:srcRect t="7811" b="7811"/>
           <a:stretch>
             <a:fillRect/>
           </a:stretch>
@@ -5288,8 +5288,8 @@
           <p:nvPr/>
         </p:nvPicPr>
         <p:blipFill>
-          <a:blip r:embed="rId3"/>
-          <a:srcRect t="35962" b="35962"/>
+          <a:blip r:embed="rId4"/>
+          <a:srcRect t="7811" b="7811"/>
           <a:stretch>
             <a:fillRect/>
           </a:stretch>
@@ -9725,7 +9725,7 @@
       </p:sp>
       <p:pic>
         <p:nvPicPr>
-          <p:cNvPr id="33" name="Picture 32" descr="current.png"/>
+          <p:cNvPr id="33" name="Picture 32" descr="image.png"/>
           <p:cNvPicPr>
             <a:picLocks noChangeAspect="1"/>
           </p:cNvPicPr>
@@ -9749,7 +9749,7 @@
       </p:pic>
       <p:pic>
         <p:nvPicPr>
-          <p:cNvPr id="34" name="Picture 33" descr="terrapods.png"/>
+          <p:cNvPr id="34" name="Picture 33" descr="image.png"/>
           <p:cNvPicPr>
             <a:picLocks noChangeAspect="1"/>
           </p:cNvPicPr>
@@ -9773,7 +9773,7 @@
       </p:pic>
       <p:pic>
         <p:nvPicPr>
-          <p:cNvPr id="35" name="Picture 34" descr="resco.png"/>
+          <p:cNvPr id="35" name="Picture 34" descr="image.png"/>
           <p:cNvPicPr>
             <a:picLocks noChangeAspect="1"/>
           </p:cNvPicPr>
@@ -9797,7 +9797,7 @@
       </p:pic>
       <p:pic>
         <p:nvPicPr>
-          <p:cNvPr id="36" name="Picture 35" descr="commercial-solutions.png"/>
+          <p:cNvPr id="36" name="Picture 35" descr="image.png"/>
           <p:cNvPicPr>
             <a:picLocks noChangeAspect="1"/>
           </p:cNvPicPr>
@@ -9821,7 +9821,7 @@
       </p:pic>
       <p:pic>
         <p:nvPicPr>
-          <p:cNvPr id="37" name="Picture 36" descr="nafta.png"/>
+          <p:cNvPr id="37" name="Picture 36" descr="image.png"/>
           <p:cNvPicPr>
             <a:picLocks noChangeAspect="1"/>
           </p:cNvPicPr>
@@ -9845,7 +9845,7 @@
       </p:pic>
       <p:pic>
         <p:nvPicPr>
-          <p:cNvPr id="38" name="Picture 37" descr="underterra.png"/>
+          <p:cNvPr id="38" name="Picture 37" descr="image.png"/>
           <p:cNvPicPr>
             <a:picLocks noChangeAspect="1"/>
           </p:cNvPicPr>
@@ -9869,7 +9869,7 @@
       </p:pic>
       <p:pic>
         <p:nvPicPr>
-          <p:cNvPr id="39" name="Picture 38" descr="becksteel.png"/>
+          <p:cNvPr id="39" name="Picture 38" descr="image.png"/>
           <p:cNvPicPr>
             <a:picLocks noChangeAspect="1"/>
           </p:cNvPicPr>
@@ -9893,7 +9893,7 @@
       </p:pic>
       <p:pic>
         <p:nvPicPr>
-          <p:cNvPr id="40" name="Picture 39" descr="sanford.png"/>
+          <p:cNvPr id="40" name="Picture 39" descr="image.png"/>
           <p:cNvPicPr>
             <a:picLocks noChangeAspect="1"/>
           </p:cNvPicPr>
@@ -9917,7 +9917,7 @@
       </p:pic>
       <p:pic>
         <p:nvPicPr>
-          <p:cNvPr id="41" name="Picture 40" descr="doerfer.png"/>
+          <p:cNvPr id="41" name="Picture 40" descr="image.png"/>
           <p:cNvPicPr>
             <a:picLocks noChangeAspect="1"/>
           </p:cNvPicPr>
@@ -9941,7 +9941,7 @@
       </p:pic>
       <p:pic>
         <p:nvPicPr>
-          <p:cNvPr id="42" name="Picture 41" descr="ge.png"/>
+          <p:cNvPr id="42" name="Picture 41" descr="image.png"/>
           <p:cNvPicPr>
             <a:picLocks noChangeAspect="1"/>
           </p:cNvPicPr>
@@ -9965,7 +9965,7 @@
       </p:pic>
       <p:pic>
         <p:nvPicPr>
-          <p:cNvPr id="43" name="Picture 42" descr="parkohio.png"/>
+          <p:cNvPr id="43" name="Picture 42" descr="image.png"/>
           <p:cNvPicPr>
             <a:picLocks noChangeAspect="1"/>
           </p:cNvPicPr>
@@ -9989,7 +9989,7 @@
       </p:pic>
       <p:pic>
         <p:nvPicPr>
-          <p:cNvPr id="44" name="Picture 43" descr="csi.png"/>
+          <p:cNvPr id="44" name="Picture 43" descr="image.png"/>
           <p:cNvPicPr>
             <a:picLocks noChangeAspect="1"/>
           </p:cNvPicPr>
@@ -10013,7 +10013,7 @@
       </p:pic>
       <p:pic>
         <p:nvPicPr>
-          <p:cNvPr id="45" name="Picture 44" descr="general-aluminum.png"/>
+          <p:cNvPr id="45" name="Picture 44" descr="image.png"/>
           <p:cNvPicPr>
             <a:picLocks noChangeAspect="1"/>
           </p:cNvPicPr>
@@ -13931,15 +13931,15 @@
       </p:sp>
       <p:pic>
         <p:nvPicPr>
-          <p:cNvPr id="13" name="Picture 12" descr="08-customs-officer.jpg"/>
+          <p:cNvPr id="13" name="Picture 12" descr="10-aerial-logistics.jpg"/>
           <p:cNvPicPr>
             <a:picLocks noChangeAspect="1"/>
           </p:cNvPicPr>
           <p:nvPr/>
         </p:nvPicPr>
         <p:blipFill>
-          <a:blip r:embed="rId3"/>
-          <a:srcRect t="35962" b="35962"/>
+          <a:blip r:embed="rId4"/>
+          <a:srcRect t="7811" b="7811"/>
           <a:stretch>
             <a:fillRect/>
           </a:stretch>
@@ -16310,15 +16310,15 @@
       </p:sp>
       <p:pic>
         <p:nvPicPr>
-          <p:cNvPr id="13" name="Picture 12" descr="10-aerial-logistics.jpg"/>
+          <p:cNvPr id="13" name="Picture 12" descr="06-world-map.jpg"/>
           <p:cNvPicPr>
             <a:picLocks noChangeAspect="1"/>
           </p:cNvPicPr>
           <p:nvPr/>
         </p:nvPicPr>
         <p:blipFill>
-          <a:blip r:embed="rId3"/>
-          <a:srcRect t="35962" b="35962"/>
+          <a:blip r:embed="rId4"/>
+          <a:srcRect t="7811" b="7811"/>
           <a:stretch>
             <a:fillRect/>
           </a:stretch>

</xml_diff>